<commit_message>
Redovisning, min del gjord
</commit_message>
<xml_diff>
--- a/Redovisning.pptx
+++ b/Redovisning.pptx
@@ -5,21 +5,24 @@
     <p:sldMasterId id="2147483744" r:id="rId4"/>
   </p:sldMasterIdLst>
   <p:notesMasterIdLst>
-    <p:notesMasterId r:id="rId14"/>
+    <p:notesMasterId r:id="rId17"/>
   </p:notesMasterIdLst>
   <p:handoutMasterIdLst>
-    <p:handoutMasterId r:id="rId15"/>
+    <p:handoutMasterId r:id="rId18"/>
   </p:handoutMasterIdLst>
   <p:sldIdLst>
     <p:sldId id="355" r:id="rId5"/>
     <p:sldId id="345" r:id="rId6"/>
     <p:sldId id="372" r:id="rId7"/>
     <p:sldId id="367" r:id="rId8"/>
-    <p:sldId id="376" r:id="rId9"/>
-    <p:sldId id="343" r:id="rId10"/>
-    <p:sldId id="341" r:id="rId11"/>
-    <p:sldId id="369" r:id="rId12"/>
-    <p:sldId id="377" r:id="rId13"/>
+    <p:sldId id="378" r:id="rId9"/>
+    <p:sldId id="379" r:id="rId10"/>
+    <p:sldId id="380" r:id="rId11"/>
+    <p:sldId id="376" r:id="rId12"/>
+    <p:sldId id="341" r:id="rId13"/>
+    <p:sldId id="343" r:id="rId14"/>
+    <p:sldId id="369" r:id="rId15"/>
+    <p:sldId id="377" r:id="rId16"/>
   </p:sldIdLst>
   <p:sldSz cx="12192000" cy="6858000"/>
   <p:notesSz cx="6858000" cy="9144000"/>
@@ -2339,28 +2342,10 @@
         <a:prstGeom prst="rect">
           <a:avLst/>
         </a:prstGeom>
-        <a:blipFill dpi="0" rotWithShape="1">
-          <a:blip xmlns:r="http://schemas.openxmlformats.org/officeDocument/2006/relationships" r:embed="rId1" cstate="screen">
-            <a:extLst>
-              <a:ext uri="{28A0092B-C50C-407E-A947-70E740481C1C}">
-                <a14:useLocalDpi xmlns:a14="http://schemas.microsoft.com/office/drawing/2010/main" val="0"/>
-              </a:ext>
-            </a:extLst>
-          </a:blip>
-          <a:srcRect/>
-          <a:stretch>
-            <a:fillRect/>
-          </a:stretch>
-        </a:blipFill>
         <a:ln>
           <a:noFill/>
         </a:ln>
       </dgm:spPr>
-      <dgm:extLst>
-        <a:ext uri="{E40237B7-FDA0-4F09-8148-C483321AD2D9}">
-          <dgm14:cNvPr xmlns:dgm14="http://schemas.microsoft.com/office/drawing/2010/diagram" id="0" name="" descr="team member headshot"/>
-        </a:ext>
-      </dgm:extLst>
     </dgm:pt>
     <dgm:pt modelId="{EE33220B-2292-4F19-BD6E-B7F529CD8414}" type="pres">
       <dgm:prSet presAssocID="{23CA95F9-8BCF-40C1-B842-BCFFD43632F6}" presName="iconSpace" presStyleCnt="0"/>
@@ -2407,28 +2392,10 @@
         <a:prstGeom prst="rect">
           <a:avLst/>
         </a:prstGeom>
-        <a:blipFill dpi="0" rotWithShape="1">
-          <a:blip xmlns:r="http://schemas.openxmlformats.org/officeDocument/2006/relationships" r:embed="rId2" cstate="screen">
-            <a:extLst>
-              <a:ext uri="{28A0092B-C50C-407E-A947-70E740481C1C}">
-                <a14:useLocalDpi xmlns:a14="http://schemas.microsoft.com/office/drawing/2010/main" val="0"/>
-              </a:ext>
-            </a:extLst>
-          </a:blip>
-          <a:srcRect/>
-          <a:stretch>
-            <a:fillRect/>
-          </a:stretch>
-        </a:blipFill>
         <a:ln>
           <a:noFill/>
         </a:ln>
       </dgm:spPr>
-      <dgm:extLst>
-        <a:ext uri="{E40237B7-FDA0-4F09-8148-C483321AD2D9}">
-          <dgm14:cNvPr xmlns:dgm14="http://schemas.microsoft.com/office/drawing/2010/diagram" id="0" name="" descr="team member headshot"/>
-        </a:ext>
-      </dgm:extLst>
     </dgm:pt>
     <dgm:pt modelId="{6FFE343B-847F-4D3F-A2F9-B95E826EC656}" type="pres">
       <dgm:prSet presAssocID="{1E293C9C-50F7-4DF0-A45F-EF6AA41E15B2}" presName="iconSpace" presStyleCnt="0"/>
@@ -2475,14 +2442,8 @@
         <a:prstGeom prst="rect">
           <a:avLst/>
         </a:prstGeom>
-        <a:blipFill dpi="0" rotWithShape="1">
-          <a:blip xmlns:r="http://schemas.openxmlformats.org/officeDocument/2006/relationships" r:embed="rId3" cstate="screen">
-            <a:extLst>
-              <a:ext uri="{28A0092B-C50C-407E-A947-70E740481C1C}">
-                <a14:useLocalDpi xmlns:a14="http://schemas.microsoft.com/office/drawing/2010/main" val="0"/>
-              </a:ext>
-            </a:extLst>
-          </a:blip>
+        <a:blipFill rotWithShape="1">
+          <a:blip xmlns:r="http://schemas.openxmlformats.org/officeDocument/2006/relationships" r:embed="rId1"/>
           <a:srcRect/>
           <a:stretch>
             <a:fillRect/>
@@ -2492,11 +2453,6 @@
           <a:noFill/>
         </a:ln>
       </dgm:spPr>
-      <dgm:extLst>
-        <a:ext uri="{E40237B7-FDA0-4F09-8148-C483321AD2D9}">
-          <dgm14:cNvPr xmlns:dgm14="http://schemas.microsoft.com/office/drawing/2010/diagram" id="0" name="" descr="team member headshot"/>
-        </a:ext>
-      </dgm:extLst>
     </dgm:pt>
     <dgm:pt modelId="{51349271-76B0-4CC0-A678-325A9A4D3475}" type="pres">
       <dgm:prSet presAssocID="{DA3F2F2F-B5A8-4CFD-ABCE-1BC48CD913AF}" presName="iconSpace" presStyleCnt="0"/>
@@ -2592,19 +2548,14 @@
         <a:prstGeom prst="rect">
           <a:avLst/>
         </a:prstGeom>
-        <a:blipFill dpi="0" rotWithShape="1">
-          <a:blip xmlns:r="http://schemas.openxmlformats.org/officeDocument/2006/relationships" r:embed="rId1" cstate="screen">
-            <a:extLst>
-              <a:ext uri="{28A0092B-C50C-407E-A947-70E740481C1C}">
-                <a14:useLocalDpi xmlns:a14="http://schemas.microsoft.com/office/drawing/2010/main" val="0"/>
-              </a:ext>
-            </a:extLst>
-          </a:blip>
-          <a:srcRect/>
-          <a:stretch>
-            <a:fillRect/>
-          </a:stretch>
-        </a:blipFill>
+        <a:solidFill>
+          <a:schemeClr val="accent2">
+            <a:hueOff val="0"/>
+            <a:satOff val="0"/>
+            <a:lumOff val="0"/>
+            <a:alphaOff val="0"/>
+          </a:schemeClr>
+        </a:solidFill>
         <a:ln w="12700" cap="flat" cmpd="sng" algn="ctr">
           <a:noFill/>
           <a:prstDash val="solid"/>
@@ -2768,19 +2719,14 @@
         <a:prstGeom prst="rect">
           <a:avLst/>
         </a:prstGeom>
-        <a:blipFill dpi="0" rotWithShape="1">
-          <a:blip xmlns:r="http://schemas.openxmlformats.org/officeDocument/2006/relationships" r:embed="rId2" cstate="screen">
-            <a:extLst>
-              <a:ext uri="{28A0092B-C50C-407E-A947-70E740481C1C}">
-                <a14:useLocalDpi xmlns:a14="http://schemas.microsoft.com/office/drawing/2010/main" val="0"/>
-              </a:ext>
-            </a:extLst>
-          </a:blip>
-          <a:srcRect/>
-          <a:stretch>
-            <a:fillRect/>
-          </a:stretch>
-        </a:blipFill>
+        <a:solidFill>
+          <a:schemeClr val="accent2">
+            <a:hueOff val="-199973"/>
+            <a:satOff val="-24193"/>
+            <a:lumOff val="-11569"/>
+            <a:alphaOff val="0"/>
+          </a:schemeClr>
+        </a:solidFill>
         <a:ln w="12700" cap="flat" cmpd="sng" algn="ctr">
           <a:noFill/>
           <a:prstDash val="solid"/>
@@ -2944,14 +2890,8 @@
         <a:prstGeom prst="rect">
           <a:avLst/>
         </a:prstGeom>
-        <a:blipFill dpi="0" rotWithShape="1">
-          <a:blip xmlns:r="http://schemas.openxmlformats.org/officeDocument/2006/relationships" r:embed="rId3" cstate="screen">
-            <a:extLst>
-              <a:ext uri="{28A0092B-C50C-407E-A947-70E740481C1C}">
-                <a14:useLocalDpi xmlns:a14="http://schemas.microsoft.com/office/drawing/2010/main" val="0"/>
-              </a:ext>
-            </a:extLst>
-          </a:blip>
+        <a:blipFill rotWithShape="1">
+          <a:blip xmlns:r="http://schemas.openxmlformats.org/officeDocument/2006/relationships" r:embed="rId1"/>
           <a:srcRect/>
           <a:stretch>
             <a:fillRect/>
@@ -4520,7 +4460,7 @@
             <a:pPr rtl="0"/>
             <a:fld id="{B8F4D5C6-7E28-4594-A8B2-534CF0B244E9}" type="datetime1">
               <a:rPr lang="sv-SE" smtClean="0"/>
-              <a:t>2025-03-17</a:t>
+              <a:t>2025-03-19</a:t>
             </a:fld>
             <a:endParaRPr lang="sv-SE"/>
           </a:p>
@@ -4702,7 +4642,7 @@
             <a:pPr rtl="0"/>
             <a:fld id="{770A9368-6A67-471A-9755-4139D32A53A4}" type="datetime1">
               <a:rPr lang="sv-SE" noProof="0" smtClean="0"/>
-              <a:t>2025-03-17</a:t>
+              <a:t>2025-03-19</a:t>
             </a:fld>
             <a:endParaRPr lang="sv-SE" noProof="0"/>
           </a:p>
@@ -5059,6 +4999,108 @@
 </p:notes>
 </file>
 
+<file path=ppt/notesSlides/notesSlide10.xml><?xml version="1.0" encoding="utf-8"?>
+<p:notes xmlns:a="http://schemas.openxmlformats.org/drawingml/2006/main" xmlns:r="http://schemas.openxmlformats.org/officeDocument/2006/relationships" xmlns:p="http://schemas.openxmlformats.org/presentationml/2006/main">
+  <p:cSld>
+    <p:spTree>
+      <p:nvGrpSpPr>
+        <p:cNvPr id="1" name=""/>
+        <p:cNvGrpSpPr/>
+        <p:nvPr/>
+      </p:nvGrpSpPr>
+      <p:grpSpPr>
+        <a:xfrm>
+          <a:off x="0" y="0"/>
+          <a:ext cx="0" cy="0"/>
+          <a:chOff x="0" y="0"/>
+          <a:chExt cx="0" cy="0"/>
+        </a:xfrm>
+      </p:grpSpPr>
+      <p:sp>
+        <p:nvSpPr>
+          <p:cNvPr id="2" name="Platshållare för bildobjekt 1"/>
+          <p:cNvSpPr>
+            <a:spLocks noGrp="1" noRot="1" noChangeAspect="1"/>
+          </p:cNvSpPr>
+          <p:nvPr>
+            <p:ph type="sldImg"/>
+          </p:nvPr>
+        </p:nvSpPr>
+        <p:spPr/>
+      </p:sp>
+      <p:sp>
+        <p:nvSpPr>
+          <p:cNvPr id="3" name="Platshållare för anteckningar 2"/>
+          <p:cNvSpPr>
+            <a:spLocks noGrp="1"/>
+          </p:cNvSpPr>
+          <p:nvPr>
+            <p:ph type="body" idx="1"/>
+          </p:nvPr>
+        </p:nvSpPr>
+        <p:spPr/>
+        <p:txBody>
+          <a:bodyPr rtlCol="0"/>
+          <a:lstStyle/>
+          <a:p>
+            <a:pPr marL="0" marR="0" lvl="0" indent="0" algn="l" defTabSz="914400" rtl="0" eaLnBrk="1" fontAlgn="auto" latinLnBrk="0" hangingPunct="1">
+              <a:lnSpc>
+                <a:spcPct val="100000"/>
+              </a:lnSpc>
+              <a:spcBef>
+                <a:spcPts val="0"/>
+              </a:spcBef>
+              <a:spcAft>
+                <a:spcPts val="0"/>
+              </a:spcAft>
+              <a:buClrTx/>
+              <a:buSzTx/>
+              <a:buFontTx/>
+              <a:buNone/>
+              <a:tabLst/>
+              <a:defRPr/>
+            </a:pPr>
+            <a:endParaRPr lang="sv-SE"/>
+          </a:p>
+        </p:txBody>
+      </p:sp>
+      <p:sp>
+        <p:nvSpPr>
+          <p:cNvPr id="4" name="Platshållare för bildnummer 3"/>
+          <p:cNvSpPr>
+            <a:spLocks noGrp="1"/>
+          </p:cNvSpPr>
+          <p:nvPr>
+            <p:ph type="sldNum" sz="quarter" idx="5"/>
+          </p:nvPr>
+        </p:nvSpPr>
+        <p:spPr/>
+        <p:txBody>
+          <a:bodyPr rtlCol="0"/>
+          <a:lstStyle/>
+          <a:p>
+            <a:pPr rtl="0"/>
+            <a:fld id="{EDA29696-2BE8-442F-AE32-06B5202A784A}" type="slidenum">
+              <a:rPr lang="sv-SE" smtClean="0"/>
+              <a:t>12</a:t>
+            </a:fld>
+            <a:endParaRPr lang="sv-SE"/>
+          </a:p>
+        </p:txBody>
+      </p:sp>
+    </p:spTree>
+    <p:extLst>
+      <p:ext uri="{BB962C8B-B14F-4D97-AF65-F5344CB8AC3E}">
+        <p14:creationId xmlns:p14="http://schemas.microsoft.com/office/powerpoint/2010/main" val="188017127"/>
+      </p:ext>
+    </p:extLst>
+  </p:cSld>
+  <p:clrMapOvr>
+    <a:masterClrMapping/>
+  </p:clrMapOvr>
+</p:notes>
+</file>
+
 <file path=ppt/notesSlides/notesSlide2.xml><?xml version="1.0" encoding="utf-8"?>
 <p:notes xmlns:a="http://schemas.openxmlformats.org/drawingml/2006/main" xmlns:r="http://schemas.openxmlformats.org/officeDocument/2006/relationships" xmlns:p="http://schemas.openxmlformats.org/presentationml/2006/main">
   <p:cSld>
@@ -5370,7 +5412,13 @@
   <p:cSld>
     <p:spTree>
       <p:nvGrpSpPr>
-        <p:cNvPr id="1" name=""/>
+        <p:cNvPr id="1" name="">
+          <a:extLst>
+            <a:ext uri="{FF2B5EF4-FFF2-40B4-BE49-F238E27FC236}">
+              <a16:creationId xmlns:a16="http://schemas.microsoft.com/office/drawing/2014/main" id="{F608A101-871D-291C-52BA-0F6A4A792381}"/>
+            </a:ext>
+          </a:extLst>
+        </p:cNvPr>
         <p:cNvGrpSpPr/>
         <p:nvPr/>
       </p:nvGrpSpPr>
@@ -5384,7 +5432,13 @@
       </p:grpSpPr>
       <p:sp>
         <p:nvSpPr>
-          <p:cNvPr id="2" name="Platshållare för bildobjekt 1"/>
+          <p:cNvPr id="2" name="Platshållare för bildobjekt 1">
+            <a:extLst>
+              <a:ext uri="{FF2B5EF4-FFF2-40B4-BE49-F238E27FC236}">
+                <a16:creationId xmlns:a16="http://schemas.microsoft.com/office/drawing/2014/main" id="{4F3C3DEA-B3D9-C208-DEE8-3AD4EE268E06}"/>
+              </a:ext>
+            </a:extLst>
+          </p:cNvPr>
           <p:cNvSpPr>
             <a:spLocks noGrp="1" noRot="1" noChangeAspect="1"/>
           </p:cNvSpPr>
@@ -5396,7 +5450,13 @@
       </p:sp>
       <p:sp>
         <p:nvSpPr>
-          <p:cNvPr id="3" name="Platshållare för anteckningar 2"/>
+          <p:cNvPr id="3" name="Platshållare för anteckningar 2">
+            <a:extLst>
+              <a:ext uri="{FF2B5EF4-FFF2-40B4-BE49-F238E27FC236}">
+                <a16:creationId xmlns:a16="http://schemas.microsoft.com/office/drawing/2014/main" id="{7078198D-0CF4-6DA9-FC5B-D724B61B9DD8}"/>
+              </a:ext>
+            </a:extLst>
+          </p:cNvPr>
           <p:cNvSpPr>
             <a:spLocks noGrp="1"/>
           </p:cNvSpPr>
@@ -5406,16 +5466,39 @@
         </p:nvSpPr>
         <p:spPr/>
         <p:txBody>
-          <a:bodyPr/>
+          <a:bodyPr rtlCol="0"/>
           <a:lstStyle/>
           <a:p>
+            <a:pPr marL="0" marR="0" lvl="0" indent="0" algn="l" defTabSz="914400" rtl="0" eaLnBrk="1" fontAlgn="auto" latinLnBrk="0" hangingPunct="1">
+              <a:lnSpc>
+                <a:spcPct val="100000"/>
+              </a:lnSpc>
+              <a:spcBef>
+                <a:spcPts val="0"/>
+              </a:spcBef>
+              <a:spcAft>
+                <a:spcPts val="0"/>
+              </a:spcAft>
+              <a:buClrTx/>
+              <a:buSzTx/>
+              <a:buFontTx/>
+              <a:buNone/>
+              <a:tabLst/>
+              <a:defRPr/>
+            </a:pPr>
             <a:endParaRPr lang="sv-SE"/>
           </a:p>
         </p:txBody>
       </p:sp>
       <p:sp>
         <p:nvSpPr>
-          <p:cNvPr id="4" name="Platshållare för bildnummer 3"/>
+          <p:cNvPr id="4" name="Platshållare för bildnummer 3">
+            <a:extLst>
+              <a:ext uri="{FF2B5EF4-FFF2-40B4-BE49-F238E27FC236}">
+                <a16:creationId xmlns:a16="http://schemas.microsoft.com/office/drawing/2014/main" id="{5537DA04-035E-020E-C586-162E5331BAA0}"/>
+              </a:ext>
+            </a:extLst>
+          </p:cNvPr>
           <p:cNvSpPr>
             <a:spLocks noGrp="1"/>
           </p:cNvSpPr>
@@ -5425,11 +5508,11 @@
         </p:nvSpPr>
         <p:spPr/>
         <p:txBody>
-          <a:bodyPr/>
+          <a:bodyPr rtlCol="0"/>
           <a:lstStyle/>
           <a:p>
             <a:pPr rtl="0"/>
-            <a:fld id="{A6FC84E0-A62F-42E1-8B0C-7D28DFB4787A}" type="slidenum">
+            <a:fld id="{41624F0E-DEC4-4055-BBC2-60E713F4A980}" type="slidenum">
               <a:rPr lang="sv-SE" smtClean="0"/>
               <a:t>5</a:t>
             </a:fld>
@@ -5440,7 +5523,7 @@
     </p:spTree>
     <p:extLst>
       <p:ext uri="{BB962C8B-B14F-4D97-AF65-F5344CB8AC3E}">
-        <p14:creationId xmlns:p14="http://schemas.microsoft.com/office/powerpoint/2010/main" val="1568238727"/>
+        <p14:creationId xmlns:p14="http://schemas.microsoft.com/office/powerpoint/2010/main" val="627650004"/>
       </p:ext>
     </p:extLst>
   </p:cSld>
@@ -5491,26 +5574,9 @@
         </p:nvSpPr>
         <p:spPr/>
         <p:txBody>
-          <a:bodyPr rtlCol="0"/>
+          <a:bodyPr/>
           <a:lstStyle/>
           <a:p>
-            <a:pPr marL="0" marR="0" lvl="0" indent="0" algn="l" defTabSz="914400" rtl="0" eaLnBrk="1" fontAlgn="auto" latinLnBrk="0" hangingPunct="1">
-              <a:lnSpc>
-                <a:spcPct val="100000"/>
-              </a:lnSpc>
-              <a:spcBef>
-                <a:spcPts val="0"/>
-              </a:spcBef>
-              <a:spcAft>
-                <a:spcPts val="0"/>
-              </a:spcAft>
-              <a:buClrTx/>
-              <a:buSzTx/>
-              <a:buFontTx/>
-              <a:buNone/>
-              <a:tabLst/>
-              <a:defRPr/>
-            </a:pPr>
             <a:endParaRPr lang="sv-SE"/>
           </a:p>
         </p:txBody>
@@ -5527,13 +5593,13 @@
         </p:nvSpPr>
         <p:spPr/>
         <p:txBody>
-          <a:bodyPr rtlCol="0"/>
+          <a:bodyPr/>
           <a:lstStyle/>
           <a:p>
             <a:pPr rtl="0"/>
-            <a:fld id="{41624F0E-DEC4-4055-BBC2-60E713F4A980}" type="slidenum">
+            <a:fld id="{A6FC84E0-A62F-42E1-8B0C-7D28DFB4787A}" type="slidenum">
               <a:rPr lang="sv-SE" smtClean="0"/>
-              <a:t>6</a:t>
+              <a:t>8</a:t>
             </a:fld>
             <a:endParaRPr lang="sv-SE"/>
           </a:p>
@@ -5542,7 +5608,7 @@
     </p:spTree>
     <p:extLst>
       <p:ext uri="{BB962C8B-B14F-4D97-AF65-F5344CB8AC3E}">
-        <p14:creationId xmlns:p14="http://schemas.microsoft.com/office/powerpoint/2010/main" val="3470242079"/>
+        <p14:creationId xmlns:p14="http://schemas.microsoft.com/office/powerpoint/2010/main" val="1568238727"/>
       </p:ext>
     </p:extLst>
   </p:cSld>
@@ -5635,7 +5701,7 @@
             <a:pPr rtl="0"/>
             <a:fld id="{41624F0E-DEC4-4055-BBC2-60E713F4A980}" type="slidenum">
               <a:rPr lang="sv-SE" smtClean="0"/>
-              <a:t>7</a:t>
+              <a:t>9</a:t>
             </a:fld>
             <a:endParaRPr lang="sv-SE"/>
           </a:p>
@@ -5735,9 +5801,9 @@
           <a:lstStyle/>
           <a:p>
             <a:pPr rtl="0"/>
-            <a:fld id="{EDA29696-2BE8-442F-AE32-06B5202A784A}" type="slidenum">
+            <a:fld id="{41624F0E-DEC4-4055-BBC2-60E713F4A980}" type="slidenum">
               <a:rPr lang="sv-SE" smtClean="0"/>
-              <a:t>8</a:t>
+              <a:t>10</a:t>
             </a:fld>
             <a:endParaRPr lang="sv-SE"/>
           </a:p>
@@ -5746,7 +5812,7 @@
     </p:spTree>
     <p:extLst>
       <p:ext uri="{BB962C8B-B14F-4D97-AF65-F5344CB8AC3E}">
-        <p14:creationId xmlns:p14="http://schemas.microsoft.com/office/powerpoint/2010/main" val="977106495"/>
+        <p14:creationId xmlns:p14="http://schemas.microsoft.com/office/powerpoint/2010/main" val="3470242079"/>
       </p:ext>
     </p:extLst>
   </p:cSld>
@@ -5839,7 +5905,7 @@
             <a:pPr rtl="0"/>
             <a:fld id="{EDA29696-2BE8-442F-AE32-06B5202A784A}" type="slidenum">
               <a:rPr lang="sv-SE" smtClean="0"/>
-              <a:t>9</a:t>
+              <a:t>11</a:t>
             </a:fld>
             <a:endParaRPr lang="sv-SE"/>
           </a:p>
@@ -5848,7 +5914,7 @@
     </p:spTree>
     <p:extLst>
       <p:ext uri="{BB962C8B-B14F-4D97-AF65-F5344CB8AC3E}">
-        <p14:creationId xmlns:p14="http://schemas.microsoft.com/office/powerpoint/2010/main" val="188017127"/>
+        <p14:creationId xmlns:p14="http://schemas.microsoft.com/office/powerpoint/2010/main" val="977106495"/>
       </p:ext>
     </p:extLst>
   </p:cSld>
@@ -16013,10 +16079,13 @@
               <a:t> </a:t>
             </a:r>
             <a:r>
-              <a:rPr lang="sv-SE"/>
-              <a:t>moves to champion</a:t>
-            </a:r>
-            <a:endParaRPr lang="sv-SE" dirty="0"/>
+              <a:rPr lang="sv-SE" dirty="0" err="1"/>
+              <a:t>moves</a:t>
+            </a:r>
+            <a:r>
+              <a:rPr lang="sv-SE" dirty="0"/>
+              <a:t> to champion</a:t>
+            </a:r>
           </a:p>
         </p:txBody>
       </p:sp>
@@ -16086,10 +16155,371 @@
       </p:sp>
       <p:pic>
         <p:nvPicPr>
-          <p:cNvPr id="19" name="Platshållare för bild 18" descr="Närbild av ett schackbräde">
+          <p:cNvPr id="4100" name="Picture 4" descr="Reinforcement Learning | What is Reinforcement Learning in AI">
             <a:extLst>
               <a:ext uri="{FF2B5EF4-FFF2-40B4-BE49-F238E27FC236}">
-                <a16:creationId xmlns:a16="http://schemas.microsoft.com/office/drawing/2014/main" id="{39881573-7C25-4F17-A03E-E8E1E0E88603}"/>
+                <a16:creationId xmlns:a16="http://schemas.microsoft.com/office/drawing/2014/main" id="{3E7E9DAE-6899-9E0A-165E-673910C96B91}"/>
+              </a:ext>
+            </a:extLst>
+          </p:cNvPr>
+          <p:cNvPicPr>
+            <a:picLocks noGrp="1" noChangeAspect="1" noChangeArrowheads="1"/>
+          </p:cNvPicPr>
+          <p:nvPr>
+            <p:ph type="pic" sz="quarter" idx="13"/>
+          </p:nvPr>
+        </p:nvPicPr>
+        <p:blipFill>
+          <a:blip r:embed="rId3">
+            <a:extLst>
+              <a:ext uri="{28A0092B-C50C-407E-A947-70E740481C1C}">
+                <a14:useLocalDpi xmlns:a14="http://schemas.microsoft.com/office/drawing/2010/main" val="0"/>
+              </a:ext>
+            </a:extLst>
+          </a:blip>
+          <a:srcRect l="21478" r="21478"/>
+          <a:stretch>
+            <a:fillRect/>
+          </a:stretch>
+        </p:blipFill>
+        <p:spPr bwMode="auto">
+          <a:prstGeom prst="rect">
+            <a:avLst/>
+          </a:prstGeom>
+          <a:noFill/>
+          <a:extLst>
+            <a:ext uri="{909E8E84-426E-40DD-AFC4-6F175D3DCCD1}">
+              <a14:hiddenFill xmlns:a14="http://schemas.microsoft.com/office/drawing/2010/main">
+                <a:solidFill>
+                  <a:srgbClr val="FFFFFF"/>
+                </a:solidFill>
+              </a14:hiddenFill>
+            </a:ext>
+          </a:extLst>
+        </p:spPr>
+      </p:pic>
+    </p:spTree>
+    <p:extLst>
+      <p:ext uri="{BB962C8B-B14F-4D97-AF65-F5344CB8AC3E}">
+        <p14:creationId xmlns:p14="http://schemas.microsoft.com/office/powerpoint/2010/main" val="2164937368"/>
+      </p:ext>
+    </p:extLst>
+  </p:cSld>
+  <p:clrMapOvr>
+    <a:masterClrMapping/>
+  </p:clrMapOvr>
+</p:sld>
+</file>
+
+<file path=ppt/slides/slide10.xml><?xml version="1.0" encoding="utf-8"?>
+<p:sld xmlns:a="http://schemas.openxmlformats.org/drawingml/2006/main" xmlns:r="http://schemas.openxmlformats.org/officeDocument/2006/relationships" xmlns:p="http://schemas.openxmlformats.org/presentationml/2006/main">
+  <p:cSld>
+    <p:spTree>
+      <p:nvGrpSpPr>
+        <p:cNvPr id="1" name=""/>
+        <p:cNvGrpSpPr/>
+        <p:nvPr/>
+      </p:nvGrpSpPr>
+      <p:grpSpPr>
+        <a:xfrm>
+          <a:off x="0" y="0"/>
+          <a:ext cx="0" cy="0"/>
+          <a:chOff x="0" y="0"/>
+          <a:chExt cx="0" cy="0"/>
+        </a:xfrm>
+      </p:grpSpPr>
+      <p:sp>
+        <p:nvSpPr>
+          <p:cNvPr id="14" name="Rubrik 13">
+            <a:extLst>
+              <a:ext uri="{FF2B5EF4-FFF2-40B4-BE49-F238E27FC236}">
+                <a16:creationId xmlns:a16="http://schemas.microsoft.com/office/drawing/2014/main" id="{46B9C631-3446-4121-A589-4979BD628EB1}"/>
+              </a:ext>
+            </a:extLst>
+          </p:cNvPr>
+          <p:cNvSpPr>
+            <a:spLocks noGrp="1"/>
+          </p:cNvSpPr>
+          <p:nvPr>
+            <p:ph type="title"/>
+          </p:nvPr>
+        </p:nvSpPr>
+        <p:spPr>
+          <a:xfrm>
+            <a:off x="822352" y="566127"/>
+            <a:ext cx="10531448" cy="1386498"/>
+          </a:xfrm>
+        </p:spPr>
+        <p:txBody>
+          <a:bodyPr rtlCol="0"/>
+          <a:lstStyle/>
+          <a:p>
+            <a:pPr rtl="0"/>
+            <a:r>
+              <a:rPr lang="sv-SE" dirty="0" err="1"/>
+              <a:t>Results</a:t>
+            </a:r>
+            <a:endParaRPr lang="sv-SE" dirty="0"/>
+          </a:p>
+        </p:txBody>
+      </p:sp>
+      <p:sp>
+        <p:nvSpPr>
+          <p:cNvPr id="15" name="Platshållare för datum 14">
+            <a:extLst>
+              <a:ext uri="{FF2B5EF4-FFF2-40B4-BE49-F238E27FC236}">
+                <a16:creationId xmlns:a16="http://schemas.microsoft.com/office/drawing/2014/main" id="{FD0F1781-5CFF-41D4-BAB4-468FA6D54BE6}"/>
+              </a:ext>
+            </a:extLst>
+          </p:cNvPr>
+          <p:cNvSpPr>
+            <a:spLocks noGrp="1"/>
+          </p:cNvSpPr>
+          <p:nvPr>
+            <p:ph type="dt" sz="half" idx="10"/>
+          </p:nvPr>
+        </p:nvSpPr>
+        <p:spPr>
+          <a:xfrm>
+            <a:off x="838200" y="6400800"/>
+            <a:ext cx="2743200" cy="365125"/>
+          </a:xfrm>
+        </p:spPr>
+        <p:txBody>
+          <a:bodyPr rtlCol="0"/>
+          <a:lstStyle/>
+          <a:p>
+            <a:pPr rtl="0"/>
+            <a:r>
+              <a:rPr lang="sv-SE" dirty="0"/>
+              <a:t>2/2/20XX</a:t>
+            </a:r>
+          </a:p>
+        </p:txBody>
+      </p:sp>
+      <p:sp>
+        <p:nvSpPr>
+          <p:cNvPr id="16" name="Platshållare för sidfot 15">
+            <a:extLst>
+              <a:ext uri="{FF2B5EF4-FFF2-40B4-BE49-F238E27FC236}">
+                <a16:creationId xmlns:a16="http://schemas.microsoft.com/office/drawing/2014/main" id="{480BDDCC-5A34-4999-8890-6FEAB235F564}"/>
+              </a:ext>
+            </a:extLst>
+          </p:cNvPr>
+          <p:cNvSpPr>
+            <a:spLocks noGrp="1"/>
+          </p:cNvSpPr>
+          <p:nvPr>
+            <p:ph type="ftr" sz="quarter" idx="11"/>
+          </p:nvPr>
+        </p:nvSpPr>
+        <p:spPr>
+          <a:xfrm>
+            <a:off x="4038600" y="6400800"/>
+            <a:ext cx="4114800" cy="365125"/>
+          </a:xfrm>
+        </p:spPr>
+        <p:txBody>
+          <a:bodyPr rtlCol="0"/>
+          <a:lstStyle/>
+          <a:p>
+            <a:pPr rtl="0"/>
+            <a:r>
+              <a:rPr lang="sv-SE" dirty="0"/>
+              <a:t>PRESENTATIONENS RUBRIK</a:t>
+            </a:r>
+          </a:p>
+        </p:txBody>
+      </p:sp>
+      <p:sp>
+        <p:nvSpPr>
+          <p:cNvPr id="17" name="Platshållare för bildnummer 16">
+            <a:extLst>
+              <a:ext uri="{FF2B5EF4-FFF2-40B4-BE49-F238E27FC236}">
+                <a16:creationId xmlns:a16="http://schemas.microsoft.com/office/drawing/2014/main" id="{1A5D4766-5F0E-4571-A9A2-7170EEEE17A3}"/>
+              </a:ext>
+            </a:extLst>
+          </p:cNvPr>
+          <p:cNvSpPr>
+            <a:spLocks noGrp="1"/>
+          </p:cNvSpPr>
+          <p:nvPr>
+            <p:ph type="sldNum" sz="quarter" idx="12"/>
+          </p:nvPr>
+        </p:nvSpPr>
+        <p:spPr>
+          <a:xfrm>
+            <a:off x="8610600" y="6400800"/>
+            <a:ext cx="2743200" cy="365125"/>
+          </a:xfrm>
+        </p:spPr>
+        <p:txBody>
+          <a:bodyPr rtlCol="0"/>
+          <a:lstStyle/>
+          <a:p>
+            <a:pPr rtl="0"/>
+            <a:fld id="{DFA5D71E-5CDF-4C93-8A75-5B916FDC5BEA}" type="slidenum">
+              <a:rPr lang="sv-SE" smtClean="0"/>
+              <a:pPr rtl="0"/>
+              <a:t>10</a:t>
+            </a:fld>
+            <a:endParaRPr lang="sv-SE" dirty="0"/>
+          </a:p>
+        </p:txBody>
+      </p:sp>
+      <p:graphicFrame>
+        <p:nvGraphicFramePr>
+          <p:cNvPr id="19" name="Platshållare för innehåll 18" descr="Platshållare för stapeldiagram ">
+            <a:extLst>
+              <a:ext uri="{FF2B5EF4-FFF2-40B4-BE49-F238E27FC236}">
+                <a16:creationId xmlns:a16="http://schemas.microsoft.com/office/drawing/2014/main" id="{DFA16334-7033-4BA3-9D13-E96DA2A323E7}"/>
+              </a:ext>
+            </a:extLst>
+          </p:cNvPr>
+          <p:cNvGraphicFramePr>
+            <a:graphicFrameLocks noGrp="1"/>
+          </p:cNvGraphicFramePr>
+          <p:nvPr>
+            <p:ph sz="quarter" idx="13"/>
+            <p:extLst>
+              <p:ext uri="{D42A27DB-BD31-4B8C-83A1-F6EECF244321}">
+                <p14:modId xmlns:p14="http://schemas.microsoft.com/office/powerpoint/2010/main" val="4204983057"/>
+              </p:ext>
+            </p:extLst>
+          </p:nvPr>
+        </p:nvGraphicFramePr>
+        <p:xfrm>
+          <a:off x="1335088" y="1952625"/>
+          <a:ext cx="9521825" cy="4049713"/>
+        </p:xfrm>
+        <a:graphic>
+          <a:graphicData uri="http://schemas.openxmlformats.org/drawingml/2006/chart">
+            <c:chart xmlns:c="http://schemas.openxmlformats.org/drawingml/2006/chart" xmlns:r="http://schemas.openxmlformats.org/officeDocument/2006/relationships" r:id="rId3"/>
+          </a:graphicData>
+        </a:graphic>
+      </p:graphicFrame>
+    </p:spTree>
+    <p:extLst>
+      <p:ext uri="{BB962C8B-B14F-4D97-AF65-F5344CB8AC3E}">
+        <p14:creationId xmlns:p14="http://schemas.microsoft.com/office/powerpoint/2010/main" val="1417018566"/>
+      </p:ext>
+    </p:extLst>
+  </p:cSld>
+  <p:clrMapOvr>
+    <a:masterClrMapping/>
+  </p:clrMapOvr>
+</p:sld>
+</file>
+
+<file path=ppt/slides/slide11.xml><?xml version="1.0" encoding="utf-8"?>
+<p:sld xmlns:a="http://schemas.openxmlformats.org/drawingml/2006/main" xmlns:r="http://schemas.openxmlformats.org/officeDocument/2006/relationships" xmlns:p="http://schemas.openxmlformats.org/presentationml/2006/main">
+  <p:cSld>
+    <p:spTree>
+      <p:nvGrpSpPr>
+        <p:cNvPr id="1" name=""/>
+        <p:cNvGrpSpPr/>
+        <p:nvPr/>
+      </p:nvGrpSpPr>
+      <p:grpSpPr>
+        <a:xfrm>
+          <a:off x="0" y="0"/>
+          <a:ext cx="0" cy="0"/>
+          <a:chOff x="0" y="0"/>
+          <a:chExt cx="0" cy="0"/>
+        </a:xfrm>
+      </p:grpSpPr>
+      <p:sp>
+        <p:nvSpPr>
+          <p:cNvPr id="9" name="Rubrik 8">
+            <a:extLst>
+              <a:ext uri="{FF2B5EF4-FFF2-40B4-BE49-F238E27FC236}">
+                <a16:creationId xmlns:a16="http://schemas.microsoft.com/office/drawing/2014/main" id="{34CF6D46-0668-4D53-8C59-F859F6E2F309}"/>
+              </a:ext>
+            </a:extLst>
+          </p:cNvPr>
+          <p:cNvSpPr>
+            <a:spLocks noGrp="1"/>
+          </p:cNvSpPr>
+          <p:nvPr>
+            <p:ph type="ctrTitle"/>
+          </p:nvPr>
+        </p:nvSpPr>
+        <p:spPr>
+          <a:xfrm>
+            <a:off x="5430848" y="728905"/>
+            <a:ext cx="5922952" cy="3184274"/>
+          </a:xfrm>
+        </p:spPr>
+        <p:txBody>
+          <a:bodyPr rtlCol="0"/>
+          <a:lstStyle/>
+          <a:p>
+            <a:pPr rtl="0"/>
+            <a:r>
+              <a:rPr lang="sv-SE" dirty="0" err="1"/>
+              <a:t>Discussion</a:t>
+            </a:r>
+            <a:endParaRPr lang="sv-SE" dirty="0"/>
+          </a:p>
+        </p:txBody>
+      </p:sp>
+      <p:sp>
+        <p:nvSpPr>
+          <p:cNvPr id="14" name="Underrubrik 13">
+            <a:extLst>
+              <a:ext uri="{FF2B5EF4-FFF2-40B4-BE49-F238E27FC236}">
+                <a16:creationId xmlns:a16="http://schemas.microsoft.com/office/drawing/2014/main" id="{6F5360D4-1E3B-45FC-B68E-C78D7F3797E1}"/>
+              </a:ext>
+            </a:extLst>
+          </p:cNvPr>
+          <p:cNvSpPr>
+            <a:spLocks noGrp="1"/>
+          </p:cNvSpPr>
+          <p:nvPr>
+            <p:ph type="subTitle" idx="1"/>
+          </p:nvPr>
+        </p:nvSpPr>
+        <p:spPr>
+          <a:xfrm>
+            <a:off x="5397967" y="4072044"/>
+            <a:ext cx="5942079" cy="1495379"/>
+          </a:xfrm>
+        </p:spPr>
+        <p:txBody>
+          <a:bodyPr rtlCol="0"/>
+          <a:lstStyle/>
+          <a:p>
+            <a:pPr rtl="0"/>
+            <a:r>
+              <a:rPr lang="sv-SE" dirty="0"/>
+              <a:t>In </a:t>
+            </a:r>
+            <a:r>
+              <a:rPr lang="sv-SE" dirty="0" err="1"/>
+              <a:t>hindsight</a:t>
+            </a:r>
+            <a:endParaRPr lang="sv-SE" dirty="0"/>
+          </a:p>
+          <a:p>
+            <a:pPr rtl="0"/>
+            <a:r>
+              <a:rPr lang="sv-SE" dirty="0" err="1"/>
+              <a:t>Improvements</a:t>
+            </a:r>
+            <a:endParaRPr lang="sv-SE" dirty="0"/>
+          </a:p>
+          <a:p>
+            <a:pPr rtl="0"/>
+            <a:endParaRPr lang="sv-SE" dirty="0"/>
+          </a:p>
+        </p:txBody>
+      </p:sp>
+      <p:pic>
+        <p:nvPicPr>
+          <p:cNvPr id="24" name="Platshållare för bild 23" descr="luffarschack">
+            <a:extLst>
+              <a:ext uri="{FF2B5EF4-FFF2-40B4-BE49-F238E27FC236}">
+                <a16:creationId xmlns:a16="http://schemas.microsoft.com/office/drawing/2014/main" id="{AE28B949-DD41-4FAB-9BFD-9B1865AB8C09}"/>
               </a:ext>
             </a:extLst>
           </p:cNvPr>
@@ -16102,20 +16532,429 @@
         </p:nvPicPr>
         <p:blipFill rotWithShape="1">
           <a:blip r:embed="rId3"/>
-          <a:srcRect l="18434" r="18434"/>
+          <a:srcRect t="6382" b="6382"/>
           <a:stretch/>
         </p:blipFill>
         <p:spPr>
           <a:xfrm>
-            <a:off x="6197600" y="574675"/>
-            <a:ext cx="5445125" cy="5749925"/>
+            <a:off x="679450" y="574675"/>
+            <a:ext cx="4311650" cy="2820988"/>
           </a:xfrm>
+        </p:spPr>
+      </p:pic>
+      <p:sp>
+        <p:nvSpPr>
+          <p:cNvPr id="11" name="Platshållare för datum 10">
+            <a:extLst>
+              <a:ext uri="{FF2B5EF4-FFF2-40B4-BE49-F238E27FC236}">
+                <a16:creationId xmlns:a16="http://schemas.microsoft.com/office/drawing/2014/main" id="{078A1077-0C8F-4D90-8616-EE28EC3EF632}"/>
+              </a:ext>
+            </a:extLst>
+          </p:cNvPr>
+          <p:cNvSpPr>
+            <a:spLocks noGrp="1"/>
+          </p:cNvSpPr>
+          <p:nvPr>
+            <p:ph type="dt" sz="half" idx="10"/>
+          </p:nvPr>
+        </p:nvSpPr>
+        <p:spPr/>
+        <p:txBody>
+          <a:bodyPr rtlCol="0"/>
+          <a:lstStyle/>
+          <a:p>
+            <a:pPr rtl="0"/>
+            <a:r>
+              <a:rPr lang="sv-SE"/>
+              <a:t>2/2/20XX</a:t>
+            </a:r>
+          </a:p>
+        </p:txBody>
+      </p:sp>
+      <p:sp>
+        <p:nvSpPr>
+          <p:cNvPr id="12" name="Platshållare för sidfot 11">
+            <a:extLst>
+              <a:ext uri="{FF2B5EF4-FFF2-40B4-BE49-F238E27FC236}">
+                <a16:creationId xmlns:a16="http://schemas.microsoft.com/office/drawing/2014/main" id="{A90567F7-E12B-4F4E-B800-9D1435624D66}"/>
+              </a:ext>
+            </a:extLst>
+          </p:cNvPr>
+          <p:cNvSpPr>
+            <a:spLocks noGrp="1"/>
+          </p:cNvSpPr>
+          <p:nvPr>
+            <p:ph type="ftr" sz="quarter" idx="11"/>
+          </p:nvPr>
+        </p:nvSpPr>
+        <p:spPr/>
+        <p:txBody>
+          <a:bodyPr rtlCol="0"/>
+          <a:lstStyle/>
+          <a:p>
+            <a:pPr rtl="0"/>
+            <a:r>
+              <a:rPr lang="sv-SE"/>
+              <a:t>PRESENTATIONENS RUBRIK</a:t>
+            </a:r>
+          </a:p>
+        </p:txBody>
+      </p:sp>
+      <p:sp>
+        <p:nvSpPr>
+          <p:cNvPr id="13" name="Platshållare för bildnummer 12">
+            <a:extLst>
+              <a:ext uri="{FF2B5EF4-FFF2-40B4-BE49-F238E27FC236}">
+                <a16:creationId xmlns:a16="http://schemas.microsoft.com/office/drawing/2014/main" id="{B9994D78-37C2-41B7-B7DD-EF7ED34BD407}"/>
+              </a:ext>
+            </a:extLst>
+          </p:cNvPr>
+          <p:cNvSpPr>
+            <a:spLocks noGrp="1"/>
+          </p:cNvSpPr>
+          <p:nvPr>
+            <p:ph type="sldNum" sz="quarter" idx="12"/>
+          </p:nvPr>
+        </p:nvSpPr>
+        <p:spPr/>
+        <p:txBody>
+          <a:bodyPr rtlCol="0"/>
+          <a:lstStyle/>
+          <a:p>
+            <a:pPr rtl="0"/>
+            <a:fld id="{DFA5D71E-5CDF-4C93-8A75-5B916FDC5BEA}" type="slidenum">
+              <a:rPr lang="sv-SE" smtClean="0"/>
+              <a:pPr rtl="0"/>
+              <a:t>11</a:t>
+            </a:fld>
+            <a:endParaRPr lang="sv-SE"/>
+          </a:p>
+        </p:txBody>
+      </p:sp>
+      <p:pic>
+        <p:nvPicPr>
+          <p:cNvPr id="2050" name="Picture 2" descr="How Deep Reinforcement Learning Can Take Content Marketing to the Next  Level - Contrend">
+            <a:extLst>
+              <a:ext uri="{FF2B5EF4-FFF2-40B4-BE49-F238E27FC236}">
+                <a16:creationId xmlns:a16="http://schemas.microsoft.com/office/drawing/2014/main" id="{7100340F-7A1A-71CF-BF4F-556EB50B7309}"/>
+              </a:ext>
+            </a:extLst>
+          </p:cNvPr>
+          <p:cNvPicPr>
+            <a:picLocks noGrp="1" noChangeAspect="1" noChangeArrowheads="1"/>
+          </p:cNvPicPr>
+          <p:nvPr>
+            <p:ph type="pic" sz="quarter" idx="14"/>
+          </p:nvPr>
+        </p:nvPicPr>
+        <p:blipFill>
+          <a:blip r:embed="rId4">
+            <a:extLst>
+              <a:ext uri="{28A0092B-C50C-407E-A947-70E740481C1C}">
+                <a14:useLocalDpi xmlns:a14="http://schemas.microsoft.com/office/drawing/2010/main" val="0"/>
+              </a:ext>
+            </a:extLst>
+          </a:blip>
+          <a:srcRect t="709" b="709"/>
+          <a:stretch>
+            <a:fillRect/>
+          </a:stretch>
+        </p:blipFill>
+        <p:spPr bwMode="auto">
+          <a:prstGeom prst="rect">
+            <a:avLst/>
+          </a:prstGeom>
+          <a:noFill/>
+          <a:extLst>
+            <a:ext uri="{909E8E84-426E-40DD-AFC4-6F175D3DCCD1}">
+              <a14:hiddenFill xmlns:a14="http://schemas.microsoft.com/office/drawing/2010/main">
+                <a:solidFill>
+                  <a:srgbClr val="FFFFFF"/>
+                </a:solidFill>
+              </a14:hiddenFill>
+            </a:ext>
+          </a:extLst>
         </p:spPr>
       </p:pic>
     </p:spTree>
     <p:extLst>
       <p:ext uri="{BB962C8B-B14F-4D97-AF65-F5344CB8AC3E}">
-        <p14:creationId xmlns:p14="http://schemas.microsoft.com/office/powerpoint/2010/main" val="2164937368"/>
+        <p14:creationId xmlns:p14="http://schemas.microsoft.com/office/powerpoint/2010/main" val="1670641188"/>
+      </p:ext>
+    </p:extLst>
+  </p:cSld>
+  <p:clrMapOvr>
+    <a:masterClrMapping/>
+  </p:clrMapOvr>
+</p:sld>
+</file>
+
+<file path=ppt/slides/slide12.xml><?xml version="1.0" encoding="utf-8"?>
+<p:sld xmlns:a="http://schemas.openxmlformats.org/drawingml/2006/main" xmlns:r="http://schemas.openxmlformats.org/officeDocument/2006/relationships" xmlns:p="http://schemas.openxmlformats.org/presentationml/2006/main">
+  <p:cSld>
+    <p:spTree>
+      <p:nvGrpSpPr>
+        <p:cNvPr id="1" name=""/>
+        <p:cNvGrpSpPr/>
+        <p:nvPr/>
+      </p:nvGrpSpPr>
+      <p:grpSpPr>
+        <a:xfrm>
+          <a:off x="0" y="0"/>
+          <a:ext cx="0" cy="0"/>
+          <a:chOff x="0" y="0"/>
+          <a:chExt cx="0" cy="0"/>
+        </a:xfrm>
+      </p:grpSpPr>
+      <p:sp>
+        <p:nvSpPr>
+          <p:cNvPr id="4" name="Rubrik 3">
+            <a:extLst>
+              <a:ext uri="{FF2B5EF4-FFF2-40B4-BE49-F238E27FC236}">
+                <a16:creationId xmlns:a16="http://schemas.microsoft.com/office/drawing/2014/main" id="{6F67426A-9C36-4C9E-B549-AD3B8874F193}"/>
+              </a:ext>
+            </a:extLst>
+          </p:cNvPr>
+          <p:cNvSpPr>
+            <a:spLocks noGrp="1"/>
+          </p:cNvSpPr>
+          <p:nvPr>
+            <p:ph type="ctrTitle"/>
+          </p:nvPr>
+        </p:nvSpPr>
+        <p:spPr>
+          <a:xfrm>
+            <a:off x="485634" y="728905"/>
+            <a:ext cx="5893683" cy="3184274"/>
+          </a:xfrm>
+        </p:spPr>
+        <p:txBody>
+          <a:bodyPr rtlCol="0"/>
+          <a:lstStyle/>
+          <a:p>
+            <a:pPr rtl="0"/>
+            <a:r>
+              <a:rPr lang="sv-SE" dirty="0" err="1"/>
+              <a:t>Thanks</a:t>
+            </a:r>
+            <a:r>
+              <a:rPr lang="sv-SE" dirty="0"/>
+              <a:t> for </a:t>
+            </a:r>
+            <a:r>
+              <a:rPr lang="sv-SE" dirty="0" err="1"/>
+              <a:t>listening</a:t>
+            </a:r>
+            <a:r>
+              <a:rPr lang="sv-SE" dirty="0"/>
+              <a:t>!</a:t>
+            </a:r>
+          </a:p>
+        </p:txBody>
+      </p:sp>
+      <p:sp>
+        <p:nvSpPr>
+          <p:cNvPr id="6" name="Underrubrik 5">
+            <a:extLst>
+              <a:ext uri="{FF2B5EF4-FFF2-40B4-BE49-F238E27FC236}">
+                <a16:creationId xmlns:a16="http://schemas.microsoft.com/office/drawing/2014/main" id="{A9D6F00D-881F-4920-89F9-792BA92E543D}"/>
+              </a:ext>
+            </a:extLst>
+          </p:cNvPr>
+          <p:cNvSpPr>
+            <a:spLocks noGrp="1"/>
+          </p:cNvSpPr>
+          <p:nvPr>
+            <p:ph type="body" sz="quarter" idx="14"/>
+          </p:nvPr>
+        </p:nvSpPr>
+        <p:spPr>
+          <a:xfrm>
+            <a:off x="452754" y="4092681"/>
+            <a:ext cx="5926564" cy="2500206"/>
+          </a:xfrm>
+        </p:spPr>
+        <p:txBody>
+          <a:bodyPr rtlCol="0">
+            <a:normAutofit/>
+          </a:bodyPr>
+          <a:lstStyle/>
+          <a:p>
+            <a:pPr rtl="0"/>
+            <a:r>
+              <a:rPr lang="sv-SE"/>
+              <a:t>Namn på presentatör</a:t>
+            </a:r>
+          </a:p>
+          <a:p>
+            <a:pPr rtl="0"/>
+            <a:r>
+              <a:rPr lang="sv-SE"/>
+              <a:t>E-post</a:t>
+            </a:r>
+          </a:p>
+          <a:p>
+            <a:pPr rtl="0"/>
+            <a:r>
+              <a:rPr lang="sv-SE"/>
+              <a:t>Webbplats</a:t>
+            </a:r>
+          </a:p>
+        </p:txBody>
+      </p:sp>
+      <p:sp>
+        <p:nvSpPr>
+          <p:cNvPr id="9" name="Platshållare för datum 8">
+            <a:extLst>
+              <a:ext uri="{FF2B5EF4-FFF2-40B4-BE49-F238E27FC236}">
+                <a16:creationId xmlns:a16="http://schemas.microsoft.com/office/drawing/2014/main" id="{3087E772-2F2C-4C47-BBBF-7E764029EAFA}"/>
+              </a:ext>
+            </a:extLst>
+          </p:cNvPr>
+          <p:cNvSpPr>
+            <a:spLocks noGrp="1"/>
+          </p:cNvSpPr>
+          <p:nvPr>
+            <p:ph type="dt" sz="half" idx="10"/>
+          </p:nvPr>
+        </p:nvSpPr>
+        <p:spPr>
+          <a:xfrm>
+            <a:off x="838200" y="6400800"/>
+            <a:ext cx="2743200" cy="365125"/>
+          </a:xfrm>
+        </p:spPr>
+        <p:txBody>
+          <a:bodyPr rtlCol="0"/>
+          <a:lstStyle/>
+          <a:p>
+            <a:pPr rtl="0"/>
+            <a:r>
+              <a:rPr lang="sv-SE"/>
+              <a:t>2/2/20XX</a:t>
+            </a:r>
+          </a:p>
+        </p:txBody>
+      </p:sp>
+      <p:sp>
+        <p:nvSpPr>
+          <p:cNvPr id="10" name="Platshållare för sidfot 9">
+            <a:extLst>
+              <a:ext uri="{FF2B5EF4-FFF2-40B4-BE49-F238E27FC236}">
+                <a16:creationId xmlns:a16="http://schemas.microsoft.com/office/drawing/2014/main" id="{C43915F4-91EA-41AF-93B6-5D572A9EF60D}"/>
+              </a:ext>
+            </a:extLst>
+          </p:cNvPr>
+          <p:cNvSpPr>
+            <a:spLocks noGrp="1"/>
+          </p:cNvSpPr>
+          <p:nvPr>
+            <p:ph type="ftr" sz="quarter" idx="11"/>
+          </p:nvPr>
+        </p:nvSpPr>
+        <p:spPr>
+          <a:xfrm>
+            <a:off x="3581400" y="6400800"/>
+            <a:ext cx="3657600" cy="365125"/>
+          </a:xfrm>
+        </p:spPr>
+        <p:txBody>
+          <a:bodyPr rtlCol="0"/>
+          <a:lstStyle/>
+          <a:p>
+            <a:pPr rtl="0"/>
+            <a:r>
+              <a:rPr lang="sv-SE"/>
+              <a:t>PRESENTATIONENS RUBRIK</a:t>
+            </a:r>
+          </a:p>
+        </p:txBody>
+      </p:sp>
+      <p:sp>
+        <p:nvSpPr>
+          <p:cNvPr id="16" name="Platshållare för bildnummer 15">
+            <a:extLst>
+              <a:ext uri="{FF2B5EF4-FFF2-40B4-BE49-F238E27FC236}">
+                <a16:creationId xmlns:a16="http://schemas.microsoft.com/office/drawing/2014/main" id="{64D73EFD-BA26-43EF-A3B9-C2877D8A6F02}"/>
+              </a:ext>
+            </a:extLst>
+          </p:cNvPr>
+          <p:cNvSpPr>
+            <a:spLocks noGrp="1"/>
+          </p:cNvSpPr>
+          <p:nvPr>
+            <p:ph type="sldNum" sz="quarter" idx="12"/>
+          </p:nvPr>
+        </p:nvSpPr>
+        <p:spPr>
+          <a:xfrm>
+            <a:off x="8610600" y="6400800"/>
+            <a:ext cx="2743200" cy="365125"/>
+          </a:xfrm>
+        </p:spPr>
+        <p:txBody>
+          <a:bodyPr rtlCol="0"/>
+          <a:lstStyle/>
+          <a:p>
+            <a:pPr rtl="0"/>
+            <a:fld id="{DFA5D71E-5CDF-4C93-8A75-5B916FDC5BEA}" type="slidenum">
+              <a:rPr lang="sv-SE" smtClean="0"/>
+              <a:pPr rtl="0"/>
+              <a:t>12</a:t>
+            </a:fld>
+            <a:endParaRPr lang="sv-SE"/>
+          </a:p>
+        </p:txBody>
+      </p:sp>
+      <p:pic>
+        <p:nvPicPr>
+          <p:cNvPr id="3074" name="Picture 2" descr="35,400+ Exhausted People Stock Illustrations, Royalty-Free Vector Graphics  &amp; Clip Art - iStock">
+            <a:extLst>
+              <a:ext uri="{FF2B5EF4-FFF2-40B4-BE49-F238E27FC236}">
+                <a16:creationId xmlns:a16="http://schemas.microsoft.com/office/drawing/2014/main" id="{4E05C1FD-C46D-360E-1A18-CB676A193E5F}"/>
+              </a:ext>
+            </a:extLst>
+          </p:cNvPr>
+          <p:cNvPicPr>
+            <a:picLocks noGrp="1" noChangeAspect="1" noChangeArrowheads="1"/>
+          </p:cNvPicPr>
+          <p:nvPr>
+            <p:ph type="pic" sz="quarter" idx="13"/>
+          </p:nvPr>
+        </p:nvPicPr>
+        <p:blipFill>
+          <a:blip r:embed="rId3">
+            <a:extLst>
+              <a:ext uri="{28A0092B-C50C-407E-A947-70E740481C1C}">
+                <a14:useLocalDpi xmlns:a14="http://schemas.microsoft.com/office/drawing/2010/main" val="0"/>
+              </a:ext>
+            </a:extLst>
+          </a:blip>
+          <a:srcRect l="14560" r="14560"/>
+          <a:stretch>
+            <a:fillRect/>
+          </a:stretch>
+        </p:blipFill>
+        <p:spPr bwMode="auto">
+          <a:prstGeom prst="rect">
+            <a:avLst/>
+          </a:prstGeom>
+          <a:noFill/>
+          <a:extLst>
+            <a:ext uri="{909E8E84-426E-40DD-AFC4-6F175D3DCCD1}">
+              <a14:hiddenFill xmlns:a14="http://schemas.microsoft.com/office/drawing/2010/main">
+                <a:solidFill>
+                  <a:srgbClr val="FFFFFF"/>
+                </a:solidFill>
+              </a14:hiddenFill>
+            </a:ext>
+          </a:extLst>
+        </p:spPr>
+      </p:pic>
+    </p:spTree>
+    <p:extLst>
+      <p:ext uri="{BB962C8B-B14F-4D97-AF65-F5344CB8AC3E}">
+        <p14:creationId xmlns:p14="http://schemas.microsoft.com/office/powerpoint/2010/main" val="279754773"/>
       </p:ext>
     </p:extLst>
   </p:cSld>
@@ -16300,7 +17139,7 @@
             <p:ph sz="quarter" idx="13"/>
             <p:extLst>
               <p:ext uri="{D42A27DB-BD31-4B8C-83A1-F6EECF244321}">
-                <p14:modId xmlns:p14="http://schemas.microsoft.com/office/powerpoint/2010/main" val="2851424712"/>
+                <p14:modId xmlns:p14="http://schemas.microsoft.com/office/powerpoint/2010/main" val="87551306"/>
               </p:ext>
             </p:extLst>
           </p:nvPr>
@@ -16381,34 +17220,6 @@
       </p:sp>
       <p:pic>
         <p:nvPicPr>
-          <p:cNvPr id="28" name="Platshållare för bild 27" descr="Närbild av ett schackbräde">
-            <a:extLst>
-              <a:ext uri="{FF2B5EF4-FFF2-40B4-BE49-F238E27FC236}">
-                <a16:creationId xmlns:a16="http://schemas.microsoft.com/office/drawing/2014/main" id="{418F3B9B-6683-4DCF-8F6A-173C94E52CEC}"/>
-              </a:ext>
-            </a:extLst>
-          </p:cNvPr>
-          <p:cNvPicPr>
-            <a:picLocks noGrp="1" noChangeAspect="1"/>
-          </p:cNvPicPr>
-          <p:nvPr>
-            <p:ph type="pic" sz="quarter" idx="13"/>
-          </p:nvPr>
-        </p:nvPicPr>
-        <p:blipFill rotWithShape="1">
-          <a:blip r:embed="rId3"/>
-          <a:srcRect t="10670" b="10670"/>
-          <a:stretch/>
-        </p:blipFill>
-        <p:spPr>
-          <a:xfrm>
-            <a:off x="542925" y="574675"/>
-            <a:ext cx="4022725" cy="1867360"/>
-          </a:xfrm>
-        </p:spPr>
-      </p:pic>
-      <p:pic>
-        <p:nvPicPr>
           <p:cNvPr id="13" name="Platshållare för bild 12" descr="Kugghjul som brainstormar">
             <a:extLst>
               <a:ext uri="{FF2B5EF4-FFF2-40B4-BE49-F238E27FC236}">
@@ -16424,7 +17235,7 @@
           </p:nvPr>
         </p:nvPicPr>
         <p:blipFill rotWithShape="1">
-          <a:blip r:embed="rId4" cstate="screen">
+          <a:blip r:embed="rId3" cstate="screen">
             <a:extLst>
               <a:ext uri="{28A0092B-C50C-407E-A947-70E740481C1C}">
                 <a14:useLocalDpi xmlns:a14="http://schemas.microsoft.com/office/drawing/2010/main" val="0"/>
@@ -16441,40 +17252,6 @@
           </a:xfrm>
         </p:spPr>
       </p:pic>
-      <p:pic>
-        <p:nvPicPr>
-          <p:cNvPr id="19" name="Platshållare för bild 18" descr="Närbild av grå schackpjäs som kastar en skugga">
-            <a:extLst>
-              <a:ext uri="{FF2B5EF4-FFF2-40B4-BE49-F238E27FC236}">
-                <a16:creationId xmlns:a16="http://schemas.microsoft.com/office/drawing/2014/main" id="{4DDD4EE5-D9CF-4433-8027-E8390EC16D11}"/>
-              </a:ext>
-            </a:extLst>
-          </p:cNvPr>
-          <p:cNvPicPr>
-            <a:picLocks noGrp="1" noChangeAspect="1"/>
-          </p:cNvPicPr>
-          <p:nvPr>
-            <p:ph type="pic" sz="quarter" idx="15"/>
-          </p:nvPr>
-        </p:nvPicPr>
-        <p:blipFill rotWithShape="1">
-          <a:blip r:embed="rId5" cstate="screen">
-            <a:extLst>
-              <a:ext uri="{28A0092B-C50C-407E-A947-70E740481C1C}">
-                <a14:useLocalDpi xmlns:a14="http://schemas.microsoft.com/office/drawing/2010/main" val="0"/>
-              </a:ext>
-            </a:extLst>
-          </a:blip>
-          <a:srcRect/>
-          <a:stretch/>
-        </p:blipFill>
-        <p:spPr>
-          <a:xfrm>
-            <a:off x="542925" y="4439331"/>
-            <a:ext cx="4022725" cy="1879333"/>
-          </a:xfrm>
-        </p:spPr>
-      </p:pic>
       <p:sp>
         <p:nvSpPr>
           <p:cNvPr id="17" name="Platshållare för innehåll 16">
@@ -16538,7 +17315,7 @@
             </a:r>
             <a:r>
               <a:rPr lang="sv-SE" dirty="0" err="1"/>
-              <a:t>discussion</a:t>
+              <a:t>Discussion</a:t>
             </a:r>
             <a:endParaRPr lang="sv-SE" dirty="0"/>
           </a:p>
@@ -16652,6 +17429,76 @@
               <a:pPr rtl="0"/>
               <a:t>3</a:t>
             </a:fld>
+            <a:endParaRPr lang="sv-SE"/>
+          </a:p>
+        </p:txBody>
+      </p:sp>
+      <p:pic>
+        <p:nvPicPr>
+          <p:cNvPr id="1034" name="Picture 10" descr="Why Reinforcement Learning Matters in Business | CDOTrends">
+            <a:extLst>
+              <a:ext uri="{FF2B5EF4-FFF2-40B4-BE49-F238E27FC236}">
+                <a16:creationId xmlns:a16="http://schemas.microsoft.com/office/drawing/2014/main" id="{0696AD37-E615-241F-76DB-67475846278B}"/>
+              </a:ext>
+            </a:extLst>
+          </p:cNvPr>
+          <p:cNvPicPr>
+            <a:picLocks noGrp="1" noChangeAspect="1" noChangeArrowheads="1"/>
+          </p:cNvPicPr>
+          <p:nvPr>
+            <p:ph type="pic" sz="quarter" idx="15"/>
+          </p:nvPr>
+        </p:nvPicPr>
+        <p:blipFill>
+          <a:blip r:embed="rId4">
+            <a:extLst>
+              <a:ext uri="{28A0092B-C50C-407E-A947-70E740481C1C}">
+                <a14:useLocalDpi xmlns:a14="http://schemas.microsoft.com/office/drawing/2010/main" val="0"/>
+              </a:ext>
+            </a:extLst>
+          </a:blip>
+          <a:srcRect t="14957" b="14957"/>
+          <a:stretch>
+            <a:fillRect/>
+          </a:stretch>
+        </p:blipFill>
+        <p:spPr bwMode="auto">
+          <a:prstGeom prst="rect">
+            <a:avLst/>
+          </a:prstGeom>
+          <a:noFill/>
+          <a:extLst>
+            <a:ext uri="{909E8E84-426E-40DD-AFC4-6F175D3DCCD1}">
+              <a14:hiddenFill xmlns:a14="http://schemas.microsoft.com/office/drawing/2010/main">
+                <a:solidFill>
+                  <a:srgbClr val="FFFFFF"/>
+                </a:solidFill>
+              </a14:hiddenFill>
+            </a:ext>
+          </a:extLst>
+        </p:spPr>
+      </p:pic>
+      <p:sp>
+        <p:nvSpPr>
+          <p:cNvPr id="2" name="Picture Placeholder 1">
+            <a:extLst>
+              <a:ext uri="{FF2B5EF4-FFF2-40B4-BE49-F238E27FC236}">
+                <a16:creationId xmlns:a16="http://schemas.microsoft.com/office/drawing/2014/main" id="{33CB0540-21F1-6882-6435-D93A6C182CCA}"/>
+              </a:ext>
+            </a:extLst>
+          </p:cNvPr>
+          <p:cNvSpPr>
+            <a:spLocks noGrp="1"/>
+          </p:cNvSpPr>
+          <p:nvPr>
+            <p:ph type="pic" sz="quarter" idx="13"/>
+          </p:nvPr>
+        </p:nvSpPr>
+        <p:spPr/>
+        <p:txBody>
+          <a:bodyPr/>
+          <a:lstStyle/>
+          <a:p>
             <a:endParaRPr lang="sv-SE"/>
           </a:p>
         </p:txBody>
@@ -16756,15 +17603,30 @@
             </a:r>
             <a:r>
               <a:rPr lang="sv-SE" dirty="0"/>
-              <a:t> is </a:t>
-            </a:r>
+              <a:t> is the </a:t>
+            </a:r>
+            <a:r>
+              <a:rPr lang="sv-SE" dirty="0" err="1"/>
+              <a:t>goal</a:t>
+            </a:r>
+            <a:r>
+              <a:rPr lang="sv-SE" dirty="0"/>
+              <a:t>?</a:t>
+            </a:r>
+          </a:p>
+          <a:p>
+            <a:pPr rtl="0"/>
+            <a:endParaRPr lang="sv-SE" dirty="0"/>
+          </a:p>
+          <a:p>
+            <a:pPr rtl="0"/>
             <a:r>
               <a:rPr lang="sv-SE" dirty="0" err="1"/>
               <a:t>Reinforcement</a:t>
             </a:r>
             <a:r>
               <a:rPr lang="sv-SE" dirty="0"/>
-              <a:t> Learning?</a:t>
+              <a:t> Learning + DQN</a:t>
             </a:r>
           </a:p>
           <a:p>
@@ -16774,79 +17636,21 @@
           <a:p>
             <a:pPr rtl="0"/>
             <a:r>
+              <a:rPr lang="sv-SE" dirty="0" err="1"/>
+              <a:t>Matlab</a:t>
+            </a:r>
+            <a:r>
               <a:rPr lang="sv-SE" dirty="0"/>
-              <a:t>DQN(Deep Q-</a:t>
+              <a:t> </a:t>
             </a:r>
             <a:r>
               <a:rPr lang="sv-SE" dirty="0" err="1"/>
-              <a:t>Network</a:t>
-            </a:r>
-            <a:r>
-              <a:rPr lang="sv-SE" dirty="0"/>
-              <a:t>)</a:t>
-            </a:r>
-          </a:p>
-          <a:p>
-            <a:pPr rtl="0"/>
+              <a:t>toolboxes</a:t>
+            </a:r>
             <a:endParaRPr lang="sv-SE" dirty="0"/>
-          </a:p>
-          <a:p>
-            <a:pPr rtl="0"/>
-            <a:r>
-              <a:rPr lang="sv-SE" dirty="0" err="1"/>
-              <a:t>Why</a:t>
-            </a:r>
-            <a:r>
-              <a:rPr lang="sv-SE" dirty="0"/>
-              <a:t> CNN(</a:t>
-            </a:r>
-            <a:r>
-              <a:rPr lang="sv-SE" dirty="0" err="1"/>
-              <a:t>Convolutional</a:t>
-            </a:r>
-            <a:r>
-              <a:rPr lang="sv-SE" dirty="0"/>
-              <a:t> Neural </a:t>
-            </a:r>
-            <a:r>
-              <a:rPr lang="sv-SE" dirty="0" err="1"/>
-              <a:t>Network</a:t>
-            </a:r>
-            <a:r>
-              <a:rPr lang="sv-SE" dirty="0"/>
-              <a:t>)</a:t>
-            </a:r>
           </a:p>
         </p:txBody>
       </p:sp>
-      <p:pic>
-        <p:nvPicPr>
-          <p:cNvPr id="20" name="Platshållare för bild 19" descr="Närbild av ett schackbräde">
-            <a:extLst>
-              <a:ext uri="{FF2B5EF4-FFF2-40B4-BE49-F238E27FC236}">
-                <a16:creationId xmlns:a16="http://schemas.microsoft.com/office/drawing/2014/main" id="{0BB4AD80-C4C9-48DF-AEB9-18EC3A792690}"/>
-              </a:ext>
-            </a:extLst>
-          </p:cNvPr>
-          <p:cNvPicPr>
-            <a:picLocks noGrp="1" noChangeAspect="1"/>
-          </p:cNvPicPr>
-          <p:nvPr>
-            <p:ph type="pic" sz="quarter" idx="13"/>
-          </p:nvPr>
-        </p:nvPicPr>
-        <p:blipFill rotWithShape="1">
-          <a:blip r:embed="rId3"/>
-          <a:srcRect l="5286" r="5286"/>
-          <a:stretch/>
-        </p:blipFill>
-        <p:spPr>
-          <a:xfrm>
-            <a:off x="6207125" y="2286000"/>
-            <a:ext cx="5435600" cy="4038600"/>
-          </a:xfrm>
-        </p:spPr>
-      </p:pic>
       <p:sp>
         <p:nvSpPr>
           <p:cNvPr id="13" name="Platshållare för datum 12">
@@ -17001,6 +17805,51 @@
           </a:p>
         </p:txBody>
       </p:sp>
+      <p:pic>
+        <p:nvPicPr>
+          <p:cNvPr id="1028" name="Picture 4" descr="Reinforcement Learning Ai Stock Illustrations – 604 Reinforcement Learning  Ai Stock Illustrations, Vectors &amp; Clipart - Dreamstime">
+            <a:extLst>
+              <a:ext uri="{FF2B5EF4-FFF2-40B4-BE49-F238E27FC236}">
+                <a16:creationId xmlns:a16="http://schemas.microsoft.com/office/drawing/2014/main" id="{9E7A6A03-769C-0B2C-893B-EA14549EA348}"/>
+              </a:ext>
+            </a:extLst>
+          </p:cNvPr>
+          <p:cNvPicPr>
+            <a:picLocks noGrp="1" noChangeAspect="1" noChangeArrowheads="1"/>
+          </p:cNvPicPr>
+          <p:nvPr>
+            <p:ph type="pic" sz="quarter" idx="13"/>
+          </p:nvPr>
+        </p:nvPicPr>
+        <p:blipFill>
+          <a:blip r:embed="rId3">
+            <a:extLst>
+              <a:ext uri="{28A0092B-C50C-407E-A947-70E740481C1C}">
+                <a14:useLocalDpi xmlns:a14="http://schemas.microsoft.com/office/drawing/2010/main" val="0"/>
+              </a:ext>
+            </a:extLst>
+          </a:blip>
+          <a:srcRect t="12850" b="12850"/>
+          <a:stretch>
+            <a:fillRect/>
+          </a:stretch>
+        </p:blipFill>
+        <p:spPr bwMode="auto">
+          <a:prstGeom prst="rect">
+            <a:avLst/>
+          </a:prstGeom>
+          <a:noFill/>
+          <a:extLst>
+            <a:ext uri="{909E8E84-426E-40DD-AFC4-6F175D3DCCD1}">
+              <a14:hiddenFill xmlns:a14="http://schemas.microsoft.com/office/drawing/2010/main">
+                <a:solidFill>
+                  <a:srgbClr val="FFFFFF"/>
+                </a:solidFill>
+              </a14:hiddenFill>
+            </a:ext>
+          </a:extLst>
+        </p:spPr>
+      </p:pic>
     </p:spTree>
     <p:extLst>
       <p:ext uri="{BB962C8B-B14F-4D97-AF65-F5344CB8AC3E}">
@@ -17019,7 +17868,13 @@
   <p:cSld>
     <p:spTree>
       <p:nvGrpSpPr>
-        <p:cNvPr id="1" name=""/>
+        <p:cNvPr id="1" name="">
+          <a:extLst>
+            <a:ext uri="{FF2B5EF4-FFF2-40B4-BE49-F238E27FC236}">
+              <a16:creationId xmlns:a16="http://schemas.microsoft.com/office/drawing/2014/main" id="{B4BF9BDF-794D-458B-739A-13300A6F205E}"/>
+            </a:ext>
+          </a:extLst>
+        </p:cNvPr>
         <p:cNvGrpSpPr/>
         <p:nvPr/>
       </p:nvGrpSpPr>
@@ -17033,10 +17888,10 @@
       </p:grpSpPr>
       <p:sp>
         <p:nvSpPr>
-          <p:cNvPr id="7" name="Rubrik 6">
+          <p:cNvPr id="9" name="Rubrik 8">
             <a:extLst>
               <a:ext uri="{FF2B5EF4-FFF2-40B4-BE49-F238E27FC236}">
-                <a16:creationId xmlns:a16="http://schemas.microsoft.com/office/drawing/2014/main" id="{BC31223B-F964-409B-BCFB-7D52E97E4054}"/>
+                <a16:creationId xmlns:a16="http://schemas.microsoft.com/office/drawing/2014/main" id="{8368605B-3CE0-647D-9FC9-14913D53D0AA}"/>
               </a:ext>
             </a:extLst>
           </p:cNvPr>
@@ -17049,8 +17904,8 @@
         </p:nvSpPr>
         <p:spPr>
           <a:xfrm>
-            <a:off x="822352" y="566127"/>
-            <a:ext cx="10531448" cy="1490825"/>
+            <a:off x="457199" y="566490"/>
+            <a:ext cx="11238347" cy="1502704"/>
           </a:xfrm>
         </p:spPr>
         <p:txBody>
@@ -17059,23 +17914,22 @@
           <a:p>
             <a:pPr rtl="0"/>
             <a:r>
+              <a:rPr lang="sv-SE" dirty="0" err="1"/>
+              <a:t>Reinforcement</a:t>
+            </a:r>
+            <a:r>
               <a:rPr lang="sv-SE" dirty="0"/>
-              <a:t>Implementation in </a:t>
-            </a:r>
-            <a:r>
-              <a:rPr lang="sv-SE" dirty="0" err="1"/>
-              <a:t>Matlab</a:t>
-            </a:r>
-            <a:endParaRPr lang="sv-SE" dirty="0"/>
+              <a:t> Learning</a:t>
+            </a:r>
           </a:p>
         </p:txBody>
       </p:sp>
       <p:sp>
         <p:nvSpPr>
-          <p:cNvPr id="8" name="Platshållare för text 7">
+          <p:cNvPr id="10" name="Platshållare för innehåll 9">
             <a:extLst>
               <a:ext uri="{FF2B5EF4-FFF2-40B4-BE49-F238E27FC236}">
-                <a16:creationId xmlns:a16="http://schemas.microsoft.com/office/drawing/2014/main" id="{F693D8AC-FF5F-4308-BD5D-F3629C785A2F}"/>
+                <a16:creationId xmlns:a16="http://schemas.microsoft.com/office/drawing/2014/main" id="{BD6A88B9-597D-227D-F55C-1F9B7737CD03}"/>
               </a:ext>
             </a:extLst>
           </p:cNvPr>
@@ -17083,13 +17937,13 @@
             <a:spLocks noGrp="1"/>
           </p:cNvSpPr>
           <p:nvPr>
-            <p:ph type="body" sz="quarter" idx="13"/>
+            <p:ph sz="quarter" idx="14"/>
           </p:nvPr>
         </p:nvSpPr>
         <p:spPr>
           <a:xfrm>
-            <a:off x="1001991" y="2346854"/>
-            <a:ext cx="3698345" cy="552450"/>
+            <a:off x="457201" y="2286000"/>
+            <a:ext cx="5435600" cy="4005263"/>
           </a:xfrm>
         </p:spPr>
         <p:txBody>
@@ -17100,8 +17954,43 @@
           <a:p>
             <a:pPr rtl="0"/>
             <a:r>
+              <a:rPr lang="sv-SE" dirty="0"/>
+              <a:t>Agent = AI </a:t>
+            </a:r>
+            <a:r>
               <a:rPr lang="sv-SE" dirty="0" err="1"/>
-              <a:t>Structure</a:t>
+              <a:t>Player</a:t>
+            </a:r>
+            <a:endParaRPr lang="sv-SE" dirty="0"/>
+          </a:p>
+          <a:p>
+            <a:pPr rtl="0"/>
+            <a:r>
+              <a:rPr lang="sv-SE" dirty="0" err="1"/>
+              <a:t>Enviroment</a:t>
+            </a:r>
+            <a:r>
+              <a:rPr lang="sv-SE" dirty="0"/>
+              <a:t> = </a:t>
+            </a:r>
+            <a:r>
+              <a:rPr lang="sv-SE" dirty="0" err="1"/>
+              <a:t>Connect</a:t>
+            </a:r>
+            <a:r>
+              <a:rPr lang="sv-SE" dirty="0"/>
+              <a:t> 4 game board</a:t>
+            </a:r>
+          </a:p>
+          <a:p>
+            <a:pPr rtl="0"/>
+            <a:r>
+              <a:rPr lang="sv-SE" dirty="0"/>
+              <a:t>Observation = </a:t>
+            </a:r>
+            <a:r>
+              <a:rPr lang="sv-SE" dirty="0" err="1"/>
+              <a:t>screenshot</a:t>
             </a:r>
             <a:r>
               <a:rPr lang="sv-SE" dirty="0"/>
@@ -17113,224 +18002,53 @@
             </a:r>
             <a:r>
               <a:rPr lang="sv-SE" dirty="0"/>
-              <a:t> DQN and CNN</a:t>
-            </a:r>
+              <a:t> the board</a:t>
+            </a:r>
+          </a:p>
+          <a:p>
+            <a:pPr rtl="0"/>
+            <a:r>
+              <a:rPr lang="sv-SE" dirty="0"/>
+              <a:t>Action = The </a:t>
+            </a:r>
+            <a:r>
+              <a:rPr lang="sv-SE" dirty="0" err="1"/>
+              <a:t>columns</a:t>
+            </a:r>
+            <a:endParaRPr lang="sv-SE" dirty="0"/>
+          </a:p>
+          <a:p>
+            <a:pPr rtl="0"/>
+            <a:r>
+              <a:rPr lang="sv-SE" dirty="0" err="1"/>
+              <a:t>Reward</a:t>
+            </a:r>
+            <a:r>
+              <a:rPr lang="sv-SE" dirty="0"/>
+              <a:t> = +10 for </a:t>
+            </a:r>
+            <a:r>
+              <a:rPr lang="sv-SE" dirty="0" err="1"/>
+              <a:t>win</a:t>
+            </a:r>
+            <a:r>
+              <a:rPr lang="sv-SE" dirty="0"/>
+              <a:t>, - 10 for illegal </a:t>
+            </a:r>
+            <a:r>
+              <a:rPr lang="sv-SE" dirty="0" err="1"/>
+              <a:t>move</a:t>
+            </a:r>
+            <a:endParaRPr lang="sv-SE" dirty="0"/>
           </a:p>
         </p:txBody>
       </p:sp>
       <p:sp>
         <p:nvSpPr>
-          <p:cNvPr id="9" name="Platshållare för text 8">
+          <p:cNvPr id="13" name="Platshållare för datum 12">
             <a:extLst>
               <a:ext uri="{FF2B5EF4-FFF2-40B4-BE49-F238E27FC236}">
-                <a16:creationId xmlns:a16="http://schemas.microsoft.com/office/drawing/2014/main" id="{FCA99590-DAB9-4B30-8543-1BC95BF0E583}"/>
-              </a:ext>
-            </a:extLst>
-          </p:cNvPr>
-          <p:cNvSpPr>
-            <a:spLocks noGrp="1"/>
-          </p:cNvSpPr>
-          <p:nvPr>
-            <p:ph type="body" sz="quarter" idx="14"/>
-          </p:nvPr>
-        </p:nvSpPr>
-        <p:spPr>
-          <a:xfrm>
-            <a:off x="1001641" y="2899269"/>
-            <a:ext cx="3303659" cy="3215781"/>
-          </a:xfrm>
-        </p:spPr>
-        <p:txBody>
-          <a:bodyPr rtlCol="0"/>
-          <a:lstStyle/>
-          <a:p>
-            <a:pPr rtl="0"/>
-            <a:r>
-              <a:rPr lang="sv-SE"/>
-              <a:t>Lägg till text, bilder, grafik och videoklipp. </a:t>
-            </a:r>
-          </a:p>
-          <a:p>
-            <a:pPr rtl="0"/>
-            <a:r>
-              <a:rPr lang="sv-SE"/>
-              <a:t>Lägga till övergångar, animeringar och rörelser. </a:t>
-            </a:r>
-          </a:p>
-          <a:p>
-            <a:pPr rtl="0"/>
-            <a:r>
-              <a:rPr lang="sv-SE"/>
-              <a:t>Spara på OneDrive för att komma åt dina presentationer via din dator, surfplatta eller mobil. </a:t>
-            </a:r>
-          </a:p>
-        </p:txBody>
-      </p:sp>
-      <p:sp>
-        <p:nvSpPr>
-          <p:cNvPr id="10" name="Platshållare för text 9">
-            <a:extLst>
-              <a:ext uri="{FF2B5EF4-FFF2-40B4-BE49-F238E27FC236}">
-                <a16:creationId xmlns:a16="http://schemas.microsoft.com/office/drawing/2014/main" id="{C39B7D33-F20A-4BEC-8297-45B83F439C9C}"/>
-              </a:ext>
-            </a:extLst>
-          </p:cNvPr>
-          <p:cNvSpPr>
-            <a:spLocks noGrp="1"/>
-          </p:cNvSpPr>
-          <p:nvPr>
-            <p:ph type="body" sz="quarter" idx="15"/>
-          </p:nvPr>
-        </p:nvSpPr>
-        <p:spPr>
-          <a:xfrm>
-            <a:off x="4700336" y="2346854"/>
-            <a:ext cx="3056887" cy="552450"/>
-          </a:xfrm>
-        </p:spPr>
-        <p:txBody>
-          <a:bodyPr rtlCol="0"/>
-          <a:lstStyle/>
-          <a:p>
-            <a:pPr rtl="0"/>
-            <a:r>
-              <a:rPr lang="sv-SE" dirty="0"/>
-              <a:t>Designer </a:t>
-            </a:r>
-            <a:r>
-              <a:rPr lang="sv-SE" dirty="0" err="1"/>
-              <a:t>Apps</a:t>
-            </a:r>
-            <a:endParaRPr lang="sv-SE" dirty="0"/>
-          </a:p>
-        </p:txBody>
-      </p:sp>
-      <p:sp>
-        <p:nvSpPr>
-          <p:cNvPr id="11" name="Platshållare för text 10">
-            <a:extLst>
-              <a:ext uri="{FF2B5EF4-FFF2-40B4-BE49-F238E27FC236}">
-                <a16:creationId xmlns:a16="http://schemas.microsoft.com/office/drawing/2014/main" id="{FD94F5F1-88A3-4B13-8EBA-47DAB2DF00C9}"/>
-              </a:ext>
-            </a:extLst>
-          </p:cNvPr>
-          <p:cNvSpPr>
-            <a:spLocks noGrp="1"/>
-          </p:cNvSpPr>
-          <p:nvPr>
-            <p:ph type="body" sz="quarter" idx="16"/>
-          </p:nvPr>
-        </p:nvSpPr>
-        <p:spPr>
-          <a:xfrm>
-            <a:off x="4453478" y="2899269"/>
-            <a:ext cx="3303659" cy="3215781"/>
-          </a:xfrm>
-        </p:spPr>
-        <p:txBody>
-          <a:bodyPr rtlCol="0"/>
-          <a:lstStyle/>
-          <a:p>
-            <a:pPr rtl="0"/>
-            <a:r>
-              <a:rPr lang="sv-SE"/>
-              <a:t>Öppna fönstret för Designidéer när du vill ändra bilden direkt. </a:t>
-            </a:r>
-          </a:p>
-          <a:p>
-            <a:pPr rtl="0"/>
-            <a:r>
-              <a:rPr lang="sv-SE"/>
-              <a:t>När det finns designidéer kommer vi att visa dem där. </a:t>
-            </a:r>
-          </a:p>
-        </p:txBody>
-      </p:sp>
-      <p:sp>
-        <p:nvSpPr>
-          <p:cNvPr id="12" name="Platshållare för text 11">
-            <a:extLst>
-              <a:ext uri="{FF2B5EF4-FFF2-40B4-BE49-F238E27FC236}">
-                <a16:creationId xmlns:a16="http://schemas.microsoft.com/office/drawing/2014/main" id="{A1A115CA-6CAF-4A96-ADFB-04588C1A796E}"/>
-              </a:ext>
-            </a:extLst>
-          </p:cNvPr>
-          <p:cNvSpPr>
-            <a:spLocks noGrp="1"/>
-          </p:cNvSpPr>
-          <p:nvPr>
-            <p:ph type="body" sz="quarter" idx="17"/>
-          </p:nvPr>
-        </p:nvSpPr>
-        <p:spPr>
-          <a:xfrm>
-            <a:off x="7906017" y="2333139"/>
-            <a:ext cx="3303394" cy="552450"/>
-          </a:xfrm>
-        </p:spPr>
-        <p:txBody>
-          <a:bodyPr rtlCol="0"/>
-          <a:lstStyle/>
-          <a:p>
-            <a:pPr rtl="0"/>
-            <a:r>
-              <a:rPr lang="sv-SE" dirty="0" err="1"/>
-              <a:t>Training</a:t>
-            </a:r>
-            <a:r>
-              <a:rPr lang="sv-SE" dirty="0"/>
-              <a:t> Process</a:t>
-            </a:r>
-          </a:p>
-        </p:txBody>
-      </p:sp>
-      <p:sp>
-        <p:nvSpPr>
-          <p:cNvPr id="13" name="Platshållare för text 12">
-            <a:extLst>
-              <a:ext uri="{FF2B5EF4-FFF2-40B4-BE49-F238E27FC236}">
-                <a16:creationId xmlns:a16="http://schemas.microsoft.com/office/drawing/2014/main" id="{47E9186B-E5E8-41FD-BFEE-0E574ABA486A}"/>
-              </a:ext>
-            </a:extLst>
-          </p:cNvPr>
-          <p:cNvSpPr>
-            <a:spLocks noGrp="1"/>
-          </p:cNvSpPr>
-          <p:nvPr>
-            <p:ph type="body" sz="quarter" idx="18"/>
-          </p:nvPr>
-        </p:nvSpPr>
-        <p:spPr>
-          <a:xfrm>
-            <a:off x="7905666" y="2885554"/>
-            <a:ext cx="3303659" cy="3215781"/>
-          </a:xfrm>
-        </p:spPr>
-        <p:txBody>
-          <a:bodyPr rtlCol="0"/>
-          <a:lstStyle/>
-          <a:p>
-            <a:pPr rtl="0"/>
-            <a:r>
-              <a:rPr lang="sv-SE"/>
-              <a:t>Det här PowerPoint-temat använder en egen uppsättning färger, teckensnitt och effekter för att skapa det övergripande utseendet på de här bilderna. </a:t>
-            </a:r>
-          </a:p>
-          <a:p>
-            <a:pPr rtl="0"/>
-            <a:r>
-              <a:rPr lang="sv-SE"/>
-              <a:t>PowerPoint innehåller massor av teman för att ge din presentation precis rätt personlighet. </a:t>
-            </a:r>
-          </a:p>
-        </p:txBody>
-      </p:sp>
-      <p:sp>
-        <p:nvSpPr>
-          <p:cNvPr id="14" name="Platshållare för datum 13">
-            <a:extLst>
-              <a:ext uri="{FF2B5EF4-FFF2-40B4-BE49-F238E27FC236}">
-                <a16:creationId xmlns:a16="http://schemas.microsoft.com/office/drawing/2014/main" id="{D858F0E8-5723-4917-B2F4-1959CDA57357}"/>
+                <a16:creationId xmlns:a16="http://schemas.microsoft.com/office/drawing/2014/main" id="{3E3CEA63-20A9-D292-4F55-78365FA835A8}"/>
               </a:ext>
             </a:extLst>
           </p:cNvPr>
@@ -17361,10 +18079,10 @@
       </p:sp>
       <p:sp>
         <p:nvSpPr>
-          <p:cNvPr id="15" name="Platshållare för sidfot 14">
+          <p:cNvPr id="14" name="Platshållare för sidfot 13">
             <a:extLst>
               <a:ext uri="{FF2B5EF4-FFF2-40B4-BE49-F238E27FC236}">
-                <a16:creationId xmlns:a16="http://schemas.microsoft.com/office/drawing/2014/main" id="{89CE2F29-4F13-4337-8A82-25313F29D150}"/>
+                <a16:creationId xmlns:a16="http://schemas.microsoft.com/office/drawing/2014/main" id="{CD792B42-550A-7FF6-5657-EFE7C87B9B4A}"/>
               </a:ext>
             </a:extLst>
           </p:cNvPr>
@@ -17395,10 +18113,10 @@
       </p:sp>
       <p:sp>
         <p:nvSpPr>
-          <p:cNvPr id="16" name="Platshållare för bildnummer 15">
+          <p:cNvPr id="19" name="Platshållare för bildnummer 18">
             <a:extLst>
               <a:ext uri="{FF2B5EF4-FFF2-40B4-BE49-F238E27FC236}">
-                <a16:creationId xmlns:a16="http://schemas.microsoft.com/office/drawing/2014/main" id="{B2486DC8-B909-491B-95D1-B14F3DEC88E3}"/>
+                <a16:creationId xmlns:a16="http://schemas.microsoft.com/office/drawing/2014/main" id="{481F6F00-7952-DD93-9038-F500644F43CC}"/>
               </a:ext>
             </a:extLst>
           </p:cNvPr>
@@ -17429,10 +18147,105 @@
           </a:p>
         </p:txBody>
       </p:sp>
+      <p:sp useBgFill="1">
+        <p:nvSpPr>
+          <p:cNvPr id="12" name="Ellips 11">
+            <a:extLst>
+              <a:ext uri="{FF2B5EF4-FFF2-40B4-BE49-F238E27FC236}">
+                <a16:creationId xmlns:a16="http://schemas.microsoft.com/office/drawing/2014/main" id="{D84EB613-53AB-A90E-D807-04B5A269A9E2}"/>
+              </a:ext>
+              <a:ext uri="{C183D7F6-B498-43B3-948B-1728B52AA6E4}">
+                <adec:decorative xmlns:adec="http://schemas.microsoft.com/office/drawing/2017/decorative" val="1"/>
+              </a:ext>
+            </a:extLst>
+          </p:cNvPr>
+          <p:cNvSpPr/>
+          <p:nvPr/>
+        </p:nvSpPr>
+        <p:spPr>
+          <a:xfrm rot="10800000">
+            <a:off x="11474676" y="5428705"/>
+            <a:ext cx="425081" cy="425081"/>
+          </a:xfrm>
+          <a:prstGeom prst="ellipse">
+            <a:avLst/>
+          </a:prstGeom>
+          <a:ln w="3848" cap="flat">
+            <a:noFill/>
+            <a:prstDash val="solid"/>
+            <a:miter/>
+          </a:ln>
+          <a:effectLst>
+            <a:glow rad="152400">
+              <a:srgbClr val="000000">
+                <a:alpha val="4000"/>
+              </a:srgbClr>
+            </a:glow>
+            <a:outerShdw blurRad="101600" dist="38100" dir="16200000" rotWithShape="0">
+              <a:srgbClr val="000000">
+                <a:alpha val="5000"/>
+              </a:srgbClr>
+            </a:outerShdw>
+          </a:effectLst>
+        </p:spPr>
+        <p:txBody>
+          <a:bodyPr rtlCol="0" anchor="ctr"/>
+          <a:lstStyle/>
+          <a:p>
+            <a:pPr rtl="0"/>
+            <a:endParaRPr lang="sv-SE"/>
+          </a:p>
+        </p:txBody>
+      </p:sp>
+      <p:pic>
+        <p:nvPicPr>
+          <p:cNvPr id="2052" name="Picture 4" descr="12 453 Connect four game royaltyfria fotografier och stockbilder |  Shutterstock">
+            <a:extLst>
+              <a:ext uri="{FF2B5EF4-FFF2-40B4-BE49-F238E27FC236}">
+                <a16:creationId xmlns:a16="http://schemas.microsoft.com/office/drawing/2014/main" id="{3C17778E-B507-F7EE-B86A-778276823F52}"/>
+              </a:ext>
+            </a:extLst>
+          </p:cNvPr>
+          <p:cNvPicPr>
+            <a:picLocks noGrp="1" noChangeAspect="1" noChangeArrowheads="1"/>
+          </p:cNvPicPr>
+          <p:nvPr>
+            <p:ph type="pic" sz="quarter" idx="13"/>
+          </p:nvPr>
+        </p:nvPicPr>
+        <p:blipFill>
+          <a:blip r:embed="rId3">
+            <a:extLst>
+              <a:ext uri="{28A0092B-C50C-407E-A947-70E740481C1C}">
+                <a14:useLocalDpi xmlns:a14="http://schemas.microsoft.com/office/drawing/2010/main" val="0"/>
+              </a:ext>
+            </a:extLst>
+          </a:blip>
+          <a:srcRect t="12850" b="12850"/>
+          <a:stretch>
+            <a:fillRect/>
+          </a:stretch>
+        </p:blipFill>
+        <p:spPr bwMode="auto">
+          <a:prstGeom prst="rect">
+            <a:avLst/>
+          </a:prstGeom>
+          <a:noFill/>
+          <a:extLst>
+            <a:ext uri="{909E8E84-426E-40DD-AFC4-6F175D3DCCD1}">
+              <a14:hiddenFill xmlns:a14="http://schemas.microsoft.com/office/drawing/2010/main">
+                <a:solidFill>
+                  <a:srgbClr val="FFFFFF"/>
+                </a:solidFill>
+              </a14:hiddenFill>
+            </a:ext>
+          </a:extLst>
+        </p:spPr>
+      </p:pic>
     </p:spTree>
     <p:extLst>
       <p:ext uri="{BB962C8B-B14F-4D97-AF65-F5344CB8AC3E}">
-        <p14:creationId xmlns:p14="http://schemas.microsoft.com/office/powerpoint/2010/main" val="4062003319"/>
+        <p14:creationId xmlns:p14="http://schemas.microsoft.com/office/powerpoint/2010/main" val="1126169320"/>
       </p:ext>
     </p:extLst>
   </p:cSld>
@@ -17461,10 +18274,10 @@
       </p:grpSpPr>
       <p:sp>
         <p:nvSpPr>
-          <p:cNvPr id="14" name="Rubrik 13">
+          <p:cNvPr id="8" name="Title 7">
             <a:extLst>
               <a:ext uri="{FF2B5EF4-FFF2-40B4-BE49-F238E27FC236}">
-                <a16:creationId xmlns:a16="http://schemas.microsoft.com/office/drawing/2014/main" id="{46B9C631-3446-4121-A589-4979BD628EB1}"/>
+                <a16:creationId xmlns:a16="http://schemas.microsoft.com/office/drawing/2014/main" id="{35F10920-A9F1-2D00-8F8F-F6A0C80492EF}"/>
               </a:ext>
             </a:extLst>
           </p:cNvPr>
@@ -17477,29 +18290,198 @@
         </p:nvSpPr>
         <p:spPr>
           <a:xfrm>
-            <a:off x="822352" y="566127"/>
-            <a:ext cx="10531448" cy="1386498"/>
+            <a:off x="457199" y="566490"/>
+            <a:ext cx="11238347" cy="1502704"/>
           </a:xfrm>
         </p:spPr>
         <p:txBody>
-          <a:bodyPr rtlCol="0"/>
+          <a:bodyPr anchor="ctr">
+            <a:normAutofit/>
+          </a:bodyPr>
           <a:lstStyle/>
           <a:p>
-            <a:pPr rtl="0"/>
-            <a:r>
-              <a:rPr lang="sv-SE" dirty="0" err="1"/>
-              <a:t>Results</a:t>
-            </a:r>
-            <a:endParaRPr lang="sv-SE" dirty="0"/>
+            <a:r>
+              <a:rPr lang="sv-SE"/>
+              <a:t>Deep Neural </a:t>
+            </a:r>
+            <a:r>
+              <a:rPr lang="sv-SE" err="1"/>
+              <a:t>Network</a:t>
+            </a:r>
+            <a:r>
+              <a:rPr lang="sv-SE"/>
+              <a:t> (DQN)</a:t>
+            </a:r>
           </a:p>
         </p:txBody>
       </p:sp>
       <p:sp>
         <p:nvSpPr>
-          <p:cNvPr id="15" name="Platshållare för datum 14">
+          <p:cNvPr id="9" name="Content Placeholder 8">
             <a:extLst>
               <a:ext uri="{FF2B5EF4-FFF2-40B4-BE49-F238E27FC236}">
-                <a16:creationId xmlns:a16="http://schemas.microsoft.com/office/drawing/2014/main" id="{FD0F1781-5CFF-41D4-BAB4-468FA6D54BE6}"/>
+                <a16:creationId xmlns:a16="http://schemas.microsoft.com/office/drawing/2014/main" id="{2CE43D67-0EFE-E647-9F51-A4D9C03CF128}"/>
+              </a:ext>
+            </a:extLst>
+          </p:cNvPr>
+          <p:cNvSpPr>
+            <a:spLocks noGrp="1"/>
+          </p:cNvSpPr>
+          <p:nvPr>
+            <p:ph sz="quarter" idx="14"/>
+          </p:nvPr>
+        </p:nvSpPr>
+        <p:spPr>
+          <a:xfrm>
+            <a:off x="457201" y="2286000"/>
+            <a:ext cx="5435600" cy="4005263"/>
+          </a:xfrm>
+        </p:spPr>
+        <p:txBody>
+          <a:bodyPr>
+            <a:normAutofit/>
+          </a:bodyPr>
+          <a:lstStyle/>
+          <a:p>
+            <a:r>
+              <a:rPr lang="sv-SE" dirty="0"/>
+              <a:t>Q-</a:t>
+            </a:r>
+            <a:r>
+              <a:rPr lang="sv-SE" dirty="0" err="1"/>
+              <a:t>learning</a:t>
+            </a:r>
+            <a:r>
+              <a:rPr lang="sv-SE" dirty="0"/>
+              <a:t> gives to </a:t>
+            </a:r>
+            <a:r>
+              <a:rPr lang="sv-SE" dirty="0" err="1"/>
+              <a:t>many</a:t>
+            </a:r>
+            <a:r>
+              <a:rPr lang="sv-SE" dirty="0"/>
+              <a:t> </a:t>
+            </a:r>
+            <a:r>
+              <a:rPr lang="sv-SE" dirty="0" err="1"/>
+              <a:t>numbers</a:t>
+            </a:r>
+            <a:endParaRPr lang="sv-SE" dirty="0"/>
+          </a:p>
+          <a:p>
+            <a:endParaRPr lang="sv-SE" dirty="0"/>
+          </a:p>
+          <a:p>
+            <a:r>
+              <a:rPr lang="sv-SE" dirty="0"/>
+              <a:t>A </a:t>
+            </a:r>
+            <a:r>
+              <a:rPr lang="sv-SE" dirty="0" err="1"/>
+              <a:t>network</a:t>
+            </a:r>
+            <a:r>
+              <a:rPr lang="sv-SE" dirty="0"/>
+              <a:t> </a:t>
+            </a:r>
+            <a:r>
+              <a:rPr lang="sv-SE" dirty="0" err="1"/>
+              <a:t>instead</a:t>
+            </a:r>
+            <a:r>
+              <a:rPr lang="sv-SE" dirty="0"/>
+              <a:t> </a:t>
+            </a:r>
+            <a:r>
+              <a:rPr lang="sv-SE" dirty="0" err="1"/>
+              <a:t>of</a:t>
+            </a:r>
+            <a:r>
+              <a:rPr lang="sv-SE" dirty="0"/>
+              <a:t> </a:t>
+            </a:r>
+            <a:r>
+              <a:rPr lang="sv-SE" dirty="0" err="1"/>
+              <a:t>tables</a:t>
+            </a:r>
+            <a:endParaRPr lang="sv-SE" dirty="0"/>
+          </a:p>
+          <a:p>
+            <a:endParaRPr lang="sv-SE" dirty="0"/>
+          </a:p>
+          <a:p>
+            <a:r>
+              <a:rPr lang="sv-SE" dirty="0"/>
+              <a:t>CNN for </a:t>
+            </a:r>
+            <a:r>
+              <a:rPr lang="sv-SE" dirty="0" err="1"/>
+              <a:t>pattern</a:t>
+            </a:r>
+            <a:r>
+              <a:rPr lang="sv-SE" dirty="0"/>
+              <a:t> </a:t>
+            </a:r>
+            <a:r>
+              <a:rPr lang="sv-SE" dirty="0" err="1"/>
+              <a:t>recognision</a:t>
+            </a:r>
+            <a:endParaRPr lang="sv-SE" dirty="0"/>
+          </a:p>
+        </p:txBody>
+      </p:sp>
+      <p:pic>
+        <p:nvPicPr>
+          <p:cNvPr id="10" name="Picture 10" descr="Why Reinforcement Learning Matters in Business | CDOTrends">
+            <a:extLst>
+              <a:ext uri="{FF2B5EF4-FFF2-40B4-BE49-F238E27FC236}">
+                <a16:creationId xmlns:a16="http://schemas.microsoft.com/office/drawing/2014/main" id="{BA1A7552-6410-8B8B-CBA9-A6B362060EC9}"/>
+              </a:ext>
+            </a:extLst>
+          </p:cNvPr>
+          <p:cNvPicPr>
+            <a:picLocks noChangeAspect="1" noChangeArrowheads="1"/>
+          </p:cNvPicPr>
+          <p:nvPr/>
+        </p:nvPicPr>
+        <p:blipFill>
+          <a:blip r:embed="rId2">
+            <a:extLst>
+              <a:ext uri="{28A0092B-C50C-407E-A947-70E740481C1C}">
+                <a14:useLocalDpi xmlns:a14="http://schemas.microsoft.com/office/drawing/2010/main" val="0"/>
+              </a:ext>
+            </a:extLst>
+          </a:blip>
+          <a:srcRect r="10161" b="1"/>
+          <a:stretch/>
+        </p:blipFill>
+        <p:spPr bwMode="auto">
+          <a:xfrm>
+            <a:off x="6207125" y="2286000"/>
+            <a:ext cx="5435600" cy="4038600"/>
+          </a:xfrm>
+          <a:prstGeom prst="rect">
+            <a:avLst/>
+          </a:prstGeom>
+          <a:noFill/>
+          <a:extLst>
+            <a:ext uri="{909E8E84-426E-40DD-AFC4-6F175D3DCCD1}">
+              <a14:hiddenFill xmlns:a14="http://schemas.microsoft.com/office/drawing/2010/main">
+                <a:solidFill>
+                  <a:srgbClr val="FFFFFF"/>
+                </a:solidFill>
+              </a14:hiddenFill>
+            </a:ext>
+          </a:extLst>
+        </p:spPr>
+      </p:pic>
+      <p:sp>
+        <p:nvSpPr>
+          <p:cNvPr id="5" name="Date Placeholder 4">
+            <a:extLst>
+              <a:ext uri="{FF2B5EF4-FFF2-40B4-BE49-F238E27FC236}">
+                <a16:creationId xmlns:a16="http://schemas.microsoft.com/office/drawing/2014/main" id="{FCA89644-3F49-F27C-DA67-08B413699D5A}"/>
               </a:ext>
             </a:extLst>
           </p:cNvPr>
@@ -17517,12 +18499,18 @@
           </a:xfrm>
         </p:spPr>
         <p:txBody>
-          <a:bodyPr rtlCol="0"/>
+          <a:bodyPr anchor="ctr">
+            <a:normAutofit/>
+          </a:bodyPr>
           <a:lstStyle/>
           <a:p>
-            <a:pPr rtl="0"/>
-            <a:r>
-              <a:rPr lang="sv-SE" dirty="0"/>
+            <a:pPr rtl="0">
+              <a:spcAft>
+                <a:spcPts val="600"/>
+              </a:spcAft>
+            </a:pPr>
+            <a:r>
+              <a:rPr lang="sv-SE" noProof="0"/>
               <a:t>2/2/20XX</a:t>
             </a:r>
           </a:p>
@@ -17530,10 +18518,10 @@
       </p:sp>
       <p:sp>
         <p:nvSpPr>
-          <p:cNvPr id="16" name="Platshållare för sidfot 15">
+          <p:cNvPr id="6" name="Footer Placeholder 5">
             <a:extLst>
               <a:ext uri="{FF2B5EF4-FFF2-40B4-BE49-F238E27FC236}">
-                <a16:creationId xmlns:a16="http://schemas.microsoft.com/office/drawing/2014/main" id="{480BDDCC-5A34-4999-8890-6FEAB235F564}"/>
+                <a16:creationId xmlns:a16="http://schemas.microsoft.com/office/drawing/2014/main" id="{2139DE1C-9937-A630-8540-EFE9655B7460}"/>
               </a:ext>
             </a:extLst>
           </p:cNvPr>
@@ -17551,12 +18539,18 @@
           </a:xfrm>
         </p:spPr>
         <p:txBody>
-          <a:bodyPr rtlCol="0"/>
+          <a:bodyPr anchor="ctr">
+            <a:normAutofit/>
+          </a:bodyPr>
           <a:lstStyle/>
           <a:p>
-            <a:pPr rtl="0"/>
-            <a:r>
-              <a:rPr lang="sv-SE" dirty="0"/>
+            <a:pPr rtl="0">
+              <a:spcAft>
+                <a:spcPts val="600"/>
+              </a:spcAft>
+            </a:pPr>
+            <a:r>
+              <a:rPr lang="sv-SE" noProof="0"/>
               <a:t>PRESENTATIONENS RUBRIK</a:t>
             </a:r>
           </a:p>
@@ -17564,10 +18558,10 @@
       </p:sp>
       <p:sp>
         <p:nvSpPr>
-          <p:cNvPr id="17" name="Platshållare för bildnummer 16">
+          <p:cNvPr id="7" name="Slide Number Placeholder 6">
             <a:extLst>
               <a:ext uri="{FF2B5EF4-FFF2-40B4-BE49-F238E27FC236}">
-                <a16:creationId xmlns:a16="http://schemas.microsoft.com/office/drawing/2014/main" id="{1A5D4766-5F0E-4571-A9A2-7170EEEE17A3}"/>
+                <a16:creationId xmlns:a16="http://schemas.microsoft.com/office/drawing/2014/main" id="{00F0F957-C1D9-0F5F-9514-80951E200EB8}"/>
               </a:ext>
             </a:extLst>
           </p:cNvPr>
@@ -17585,54 +18579,33 @@
           </a:xfrm>
         </p:spPr>
         <p:txBody>
-          <a:bodyPr rtlCol="0"/>
+          <a:bodyPr anchor="ctr">
+            <a:normAutofit/>
+          </a:bodyPr>
           <a:lstStyle/>
           <a:p>
-            <a:pPr rtl="0"/>
+            <a:pPr rtl="0">
+              <a:spcAft>
+                <a:spcPts val="600"/>
+              </a:spcAft>
+            </a:pPr>
             <a:fld id="{DFA5D71E-5CDF-4C93-8A75-5B916FDC5BEA}" type="slidenum">
-              <a:rPr lang="sv-SE" smtClean="0"/>
-              <a:pPr rtl="0"/>
+              <a:rPr lang="sv-SE" noProof="0" smtClean="0"/>
+              <a:pPr rtl="0">
+                <a:spcAft>
+                  <a:spcPts val="600"/>
+                </a:spcAft>
+              </a:pPr>
               <a:t>6</a:t>
             </a:fld>
-            <a:endParaRPr lang="sv-SE" dirty="0"/>
+            <a:endParaRPr lang="sv-SE" noProof="0"/>
           </a:p>
         </p:txBody>
       </p:sp>
-      <p:graphicFrame>
-        <p:nvGraphicFramePr>
-          <p:cNvPr id="19" name="Platshållare för innehåll 18" descr="Platshållare för stapeldiagram ">
-            <a:extLst>
-              <a:ext uri="{FF2B5EF4-FFF2-40B4-BE49-F238E27FC236}">
-                <a16:creationId xmlns:a16="http://schemas.microsoft.com/office/drawing/2014/main" id="{DFA16334-7033-4BA3-9D13-E96DA2A323E7}"/>
-              </a:ext>
-            </a:extLst>
-          </p:cNvPr>
-          <p:cNvGraphicFramePr>
-            <a:graphicFrameLocks noGrp="1"/>
-          </p:cNvGraphicFramePr>
-          <p:nvPr>
-            <p:ph sz="quarter" idx="13"/>
-            <p:extLst>
-              <p:ext uri="{D42A27DB-BD31-4B8C-83A1-F6EECF244321}">
-                <p14:modId xmlns:p14="http://schemas.microsoft.com/office/powerpoint/2010/main" val="4204983057"/>
-              </p:ext>
-            </p:extLst>
-          </p:nvPr>
-        </p:nvGraphicFramePr>
-        <p:xfrm>
-          <a:off x="1335088" y="1952625"/>
-          <a:ext cx="9521825" cy="4049713"/>
-        </p:xfrm>
-        <a:graphic>
-          <a:graphicData uri="http://schemas.openxmlformats.org/drawingml/2006/chart">
-            <c:chart xmlns:c="http://schemas.openxmlformats.org/drawingml/2006/chart" xmlns:r="http://schemas.openxmlformats.org/officeDocument/2006/relationships" r:id="rId3"/>
-          </a:graphicData>
-        </a:graphic>
-      </p:graphicFrame>
     </p:spTree>
     <p:extLst>
       <p:ext uri="{BB962C8B-B14F-4D97-AF65-F5344CB8AC3E}">
-        <p14:creationId xmlns:p14="http://schemas.microsoft.com/office/powerpoint/2010/main" val="1417018566"/>
+        <p14:creationId xmlns:p14="http://schemas.microsoft.com/office/powerpoint/2010/main" val="1089777163"/>
       </p:ext>
     </p:extLst>
   </p:cSld>
@@ -17661,10 +18634,10 @@
       </p:grpSpPr>
       <p:sp>
         <p:nvSpPr>
-          <p:cNvPr id="15" name="Rubrik 14">
+          <p:cNvPr id="8" name="Title 7">
             <a:extLst>
               <a:ext uri="{FF2B5EF4-FFF2-40B4-BE49-F238E27FC236}">
-                <a16:creationId xmlns:a16="http://schemas.microsoft.com/office/drawing/2014/main" id="{3DFFF8FE-0B1F-4A34-8AE0-3608529C4AF5}"/>
+                <a16:creationId xmlns:a16="http://schemas.microsoft.com/office/drawing/2014/main" id="{4C545BE7-CB99-1D63-816E-3F032AA248C8}"/>
               </a:ext>
             </a:extLst>
           </p:cNvPr>
@@ -17672,130 +18645,51 @@
             <a:spLocks noGrp="1"/>
           </p:cNvSpPr>
           <p:nvPr>
-            <p:ph type="title"/>
+            <p:ph type="ctrTitle"/>
           </p:nvPr>
         </p:nvSpPr>
-        <p:spPr>
-          <a:xfrm>
-            <a:off x="580403" y="4038599"/>
-            <a:ext cx="4715498" cy="2235494"/>
-          </a:xfrm>
-        </p:spPr>
+        <p:spPr/>
         <p:txBody>
-          <a:bodyPr rtlCol="0"/>
+          <a:bodyPr/>
           <a:lstStyle/>
           <a:p>
-            <a:pPr rtl="0"/>
+            <a:r>
+              <a:rPr lang="sv-SE" dirty="0"/>
+              <a:t>So </a:t>
+            </a:r>
             <a:r>
               <a:rPr lang="sv-SE" dirty="0" err="1"/>
-              <a:t>Discussion</a:t>
-            </a:r>
-            <a:endParaRPr lang="sv-SE" dirty="0"/>
+              <a:t>how</a:t>
+            </a:r>
+            <a:r>
+              <a:rPr lang="sv-SE" dirty="0"/>
+              <a:t> </a:t>
+            </a:r>
+            <a:r>
+              <a:rPr lang="sv-SE" dirty="0" err="1"/>
+              <a:t>does</a:t>
+            </a:r>
+            <a:r>
+              <a:rPr lang="sv-SE" dirty="0"/>
+              <a:t> it </a:t>
+            </a:r>
+            <a:r>
+              <a:rPr lang="sv-SE" dirty="0" err="1"/>
+              <a:t>work</a:t>
+            </a:r>
+            <a:r>
+              <a:rPr lang="sv-SE" dirty="0"/>
+              <a:t>?</a:t>
+            </a:r>
           </a:p>
         </p:txBody>
       </p:sp>
-      <p:pic>
-        <p:nvPicPr>
-          <p:cNvPr id="17" name="Platshållare för bild 16" descr="Närbild av ett schackbräde">
+      <p:sp>
+        <p:nvSpPr>
+          <p:cNvPr id="10" name="Text Placeholder 9">
             <a:extLst>
               <a:ext uri="{FF2B5EF4-FFF2-40B4-BE49-F238E27FC236}">
-                <a16:creationId xmlns:a16="http://schemas.microsoft.com/office/drawing/2014/main" id="{ECCAD670-7062-4CD7-93ED-6AA7C8BBFF45}"/>
-              </a:ext>
-            </a:extLst>
-          </p:cNvPr>
-          <p:cNvPicPr>
-            <a:picLocks noGrp="1" noChangeAspect="1"/>
-          </p:cNvPicPr>
-          <p:nvPr>
-            <p:ph type="pic" sz="quarter" idx="14"/>
-          </p:nvPr>
-        </p:nvPicPr>
-        <p:blipFill rotWithShape="1">
-          <a:blip r:embed="rId3" cstate="screen">
-            <a:extLst>
-              <a:ext uri="{28A0092B-C50C-407E-A947-70E740481C1C}">
-                <a14:useLocalDpi xmlns:a14="http://schemas.microsoft.com/office/drawing/2010/main" val="0"/>
-              </a:ext>
-            </a:extLst>
-          </a:blip>
-          <a:srcRect/>
-          <a:stretch/>
-        </p:blipFill>
-        <p:spPr>
-          <a:xfrm>
-            <a:off x="581025" y="533400"/>
-            <a:ext cx="3628551" cy="3297238"/>
-          </a:xfrm>
-        </p:spPr>
-      </p:pic>
-      <p:pic>
-        <p:nvPicPr>
-          <p:cNvPr id="21" name="Platshållare för bild 20" descr="Närbild av ett schackbräde">
-            <a:extLst>
-              <a:ext uri="{FF2B5EF4-FFF2-40B4-BE49-F238E27FC236}">
-                <a16:creationId xmlns:a16="http://schemas.microsoft.com/office/drawing/2014/main" id="{2591A087-C8F7-43B5-8D57-C7D61C00B2E6}"/>
-              </a:ext>
-            </a:extLst>
-          </p:cNvPr>
-          <p:cNvPicPr>
-            <a:picLocks noGrp="1" noChangeAspect="1"/>
-          </p:cNvPicPr>
-          <p:nvPr>
-            <p:ph type="pic" sz="quarter" idx="15"/>
-          </p:nvPr>
-        </p:nvPicPr>
-        <p:blipFill rotWithShape="1">
-          <a:blip r:embed="rId4" cstate="screen">
-            <a:extLst>
-              <a:ext uri="{28A0092B-C50C-407E-A947-70E740481C1C}">
-                <a14:useLocalDpi xmlns:a14="http://schemas.microsoft.com/office/drawing/2010/main" val="0"/>
-              </a:ext>
-            </a:extLst>
-          </a:blip>
-          <a:srcRect/>
-          <a:stretch/>
-        </p:blipFill>
-        <p:spPr>
-          <a:xfrm>
-            <a:off x="4291941" y="533400"/>
-            <a:ext cx="3663496" cy="3297238"/>
-          </a:xfrm>
-        </p:spPr>
-      </p:pic>
-      <p:pic>
-        <p:nvPicPr>
-          <p:cNvPr id="26" name="Platshållare för bild 25" descr="En person som visar ritningar på pappersark med en penna">
-            <a:extLst>
-              <a:ext uri="{FF2B5EF4-FFF2-40B4-BE49-F238E27FC236}">
-                <a16:creationId xmlns:a16="http://schemas.microsoft.com/office/drawing/2014/main" id="{099D8543-3EEB-4227-9701-35025090F534}"/>
-              </a:ext>
-            </a:extLst>
-          </p:cNvPr>
-          <p:cNvPicPr>
-            <a:picLocks noGrp="1" noChangeAspect="1"/>
-          </p:cNvPicPr>
-          <p:nvPr>
-            <p:ph type="pic" sz="quarter" idx="16"/>
-          </p:nvPr>
-        </p:nvPicPr>
-        <p:blipFill rotWithShape="1">
-          <a:blip r:embed="rId5"/>
-          <a:srcRect l="13072" r="13072"/>
-          <a:stretch/>
-        </p:blipFill>
-        <p:spPr>
-          <a:xfrm>
-            <a:off x="8032564" y="533400"/>
-            <a:ext cx="3653023" cy="3297238"/>
-          </a:xfrm>
-        </p:spPr>
-      </p:pic>
-      <p:sp>
-        <p:nvSpPr>
-          <p:cNvPr id="16" name="Platshållare för text 15">
-            <a:extLst>
-              <a:ext uri="{FF2B5EF4-FFF2-40B4-BE49-F238E27FC236}">
-                <a16:creationId xmlns:a16="http://schemas.microsoft.com/office/drawing/2014/main" id="{79D3D0B4-CC43-4279-8230-0E15CA6CC587}"/>
+                <a16:creationId xmlns:a16="http://schemas.microsoft.com/office/drawing/2014/main" id="{C73E2D79-123A-2BAB-76C4-682296C22FC1}"/>
               </a:ext>
             </a:extLst>
           </p:cNvPr>
@@ -17803,33 +18697,42 @@
             <a:spLocks noGrp="1"/>
           </p:cNvSpPr>
           <p:nvPr>
-            <p:ph type="body" sz="quarter" idx="13"/>
+            <p:ph type="body" sz="quarter" idx="14"/>
           </p:nvPr>
         </p:nvSpPr>
-        <p:spPr>
-          <a:xfrm>
-            <a:off x="5486400" y="4038600"/>
-            <a:ext cx="6199189" cy="2235200"/>
-          </a:xfrm>
-        </p:spPr>
+        <p:spPr/>
         <p:txBody>
-          <a:bodyPr rtlCol="0"/>
+          <a:bodyPr/>
           <a:lstStyle/>
           <a:p>
-            <a:pPr rtl="0"/>
-            <a:r>
-              <a:rPr lang="sv-SE"/>
-              <a:t>Med PowerPoint kan du skapa presentationer och dela ditt arbete med andra, oavsett var de befinner sig. Skriv in den text du vill använda för att komma igång. Du kan också lägga till bilder, konst och videor i den här mallen. Spara till OneDrive och få åtkomst till dina presentationer från din dator, surfplatta eller mobil.</a:t>
-            </a:r>
+            <a:r>
+              <a:rPr lang="sv-SE" dirty="0" err="1"/>
+              <a:t>Observe</a:t>
+            </a:r>
+            <a:endParaRPr lang="sv-SE" dirty="0"/>
+          </a:p>
+          <a:p>
+            <a:r>
+              <a:rPr lang="sv-SE" dirty="0" err="1"/>
+              <a:t>Act</a:t>
+            </a:r>
+            <a:endParaRPr lang="sv-SE" dirty="0"/>
+          </a:p>
+          <a:p>
+            <a:r>
+              <a:rPr lang="sv-SE" dirty="0" err="1"/>
+              <a:t>Reward</a:t>
+            </a:r>
+            <a:endParaRPr lang="sv-SE" dirty="0"/>
           </a:p>
         </p:txBody>
       </p:sp>
       <p:sp>
         <p:nvSpPr>
-          <p:cNvPr id="22" name="Platshållare för datum 21">
+          <p:cNvPr id="5" name="Date Placeholder 4">
             <a:extLst>
               <a:ext uri="{FF2B5EF4-FFF2-40B4-BE49-F238E27FC236}">
-                <a16:creationId xmlns:a16="http://schemas.microsoft.com/office/drawing/2014/main" id="{24499858-7E09-42AB-A3F0-2C1068A4836A}"/>
+                <a16:creationId xmlns:a16="http://schemas.microsoft.com/office/drawing/2014/main" id="{5913323C-890E-EDED-7F5B-6D1037916C82}"/>
               </a:ext>
             </a:extLst>
           </p:cNvPr>
@@ -17840,19 +18743,14 @@
             <p:ph type="dt" sz="half" idx="10"/>
           </p:nvPr>
         </p:nvSpPr>
-        <p:spPr>
-          <a:xfrm>
-            <a:off x="838200" y="6400800"/>
-            <a:ext cx="2743200" cy="365125"/>
-          </a:xfrm>
-        </p:spPr>
+        <p:spPr/>
         <p:txBody>
-          <a:bodyPr rtlCol="0"/>
+          <a:bodyPr/>
           <a:lstStyle/>
           <a:p>
             <a:pPr rtl="0"/>
             <a:r>
-              <a:rPr lang="sv-SE"/>
+              <a:rPr lang="sv-SE" noProof="0"/>
               <a:t>2/2/20XX</a:t>
             </a:r>
           </a:p>
@@ -17860,10 +18758,10 @@
       </p:sp>
       <p:sp>
         <p:nvSpPr>
-          <p:cNvPr id="23" name="Platshållare för sidfot 22">
+          <p:cNvPr id="6" name="Footer Placeholder 5">
             <a:extLst>
               <a:ext uri="{FF2B5EF4-FFF2-40B4-BE49-F238E27FC236}">
-                <a16:creationId xmlns:a16="http://schemas.microsoft.com/office/drawing/2014/main" id="{B3628A90-EE87-4FE9-AA39-875917A80C76}"/>
+                <a16:creationId xmlns:a16="http://schemas.microsoft.com/office/drawing/2014/main" id="{DB07F2D0-24C6-7A82-BDBD-7C638D38DA5D}"/>
               </a:ext>
             </a:extLst>
           </p:cNvPr>
@@ -17874,19 +18772,14 @@
             <p:ph type="ftr" sz="quarter" idx="11"/>
           </p:nvPr>
         </p:nvSpPr>
-        <p:spPr>
-          <a:xfrm>
-            <a:off x="4038600" y="6400800"/>
-            <a:ext cx="4114800" cy="365125"/>
-          </a:xfrm>
-        </p:spPr>
+        <p:spPr/>
         <p:txBody>
-          <a:bodyPr rtlCol="0"/>
+          <a:bodyPr/>
           <a:lstStyle/>
           <a:p>
             <a:pPr rtl="0"/>
             <a:r>
-              <a:rPr lang="sv-SE"/>
+              <a:rPr lang="sv-SE" noProof="0"/>
               <a:t>PRESENTATIONENS RUBRIK</a:t>
             </a:r>
           </a:p>
@@ -17894,10 +18787,35 @@
       </p:sp>
       <p:sp>
         <p:nvSpPr>
-          <p:cNvPr id="24" name="Platshållare för bildnummer 23">
+          <p:cNvPr id="9" name="Picture Placeholder 8">
             <a:extLst>
               <a:ext uri="{FF2B5EF4-FFF2-40B4-BE49-F238E27FC236}">
-                <a16:creationId xmlns:a16="http://schemas.microsoft.com/office/drawing/2014/main" id="{9481EC64-D6E1-4753-A68E-7C62AA16D214}"/>
+                <a16:creationId xmlns:a16="http://schemas.microsoft.com/office/drawing/2014/main" id="{62D52AE4-5D91-54DA-D6EA-BB6B8BFC83BD}"/>
+              </a:ext>
+            </a:extLst>
+          </p:cNvPr>
+          <p:cNvSpPr>
+            <a:spLocks noGrp="1"/>
+          </p:cNvSpPr>
+          <p:nvPr>
+            <p:ph type="pic" sz="quarter" idx="13"/>
+          </p:nvPr>
+        </p:nvSpPr>
+        <p:spPr/>
+        <p:txBody>
+          <a:bodyPr/>
+          <a:lstStyle/>
+          <a:p>
+            <a:endParaRPr lang="sv-SE"/>
+          </a:p>
+        </p:txBody>
+      </p:sp>
+      <p:sp>
+        <p:nvSpPr>
+          <p:cNvPr id="7" name="Slide Number Placeholder 6">
+            <a:extLst>
+              <a:ext uri="{FF2B5EF4-FFF2-40B4-BE49-F238E27FC236}">
+                <a16:creationId xmlns:a16="http://schemas.microsoft.com/office/drawing/2014/main" id="{8AABD8E5-7F02-7CE6-3899-63620B1D97E8}"/>
               </a:ext>
             </a:extLst>
           </p:cNvPr>
@@ -17908,88 +18826,25 @@
             <p:ph type="sldNum" sz="quarter" idx="12"/>
           </p:nvPr>
         </p:nvSpPr>
-        <p:spPr>
-          <a:xfrm>
-            <a:off x="8610600" y="6400800"/>
-            <a:ext cx="2743200" cy="365125"/>
-          </a:xfrm>
-        </p:spPr>
+        <p:spPr/>
         <p:txBody>
-          <a:bodyPr rtlCol="0"/>
+          <a:bodyPr/>
           <a:lstStyle/>
           <a:p>
             <a:pPr rtl="0"/>
             <a:fld id="{DFA5D71E-5CDF-4C93-8A75-5B916FDC5BEA}" type="slidenum">
-              <a:rPr lang="sv-SE" smtClean="0"/>
+              <a:rPr lang="sv-SE" noProof="0" smtClean="0"/>
               <a:pPr rtl="0"/>
               <a:t>7</a:t>
             </a:fld>
-            <a:endParaRPr lang="sv-SE"/>
-          </a:p>
-        </p:txBody>
-      </p:sp>
-      <p:sp>
-        <p:nvSpPr>
-          <p:cNvPr id="68" name="Platshållare för text 67">
-            <a:extLst>
-              <a:ext uri="{FF2B5EF4-FFF2-40B4-BE49-F238E27FC236}">
-                <a16:creationId xmlns:a16="http://schemas.microsoft.com/office/drawing/2014/main" id="{A19C76D3-8EEC-4408-AEBF-59B910FB5DD9}"/>
-              </a:ext>
-              <a:ext uri="{C183D7F6-B498-43B3-948B-1728B52AA6E4}">
-                <adec:decorative xmlns:adec="http://schemas.microsoft.com/office/drawing/2017/decorative" val="1"/>
-              </a:ext>
-            </a:extLst>
-          </p:cNvPr>
-          <p:cNvSpPr>
-            <a:spLocks noGrp="1"/>
-          </p:cNvSpPr>
-          <p:nvPr>
-            <p:ph type="body" sz="quarter" idx="17"/>
-          </p:nvPr>
-        </p:nvSpPr>
-        <p:spPr/>
-        <p:txBody>
-          <a:bodyPr rtlCol="0"/>
-          <a:lstStyle/>
-          <a:p>
-            <a:pPr rtl="0"/>
-            <a:endParaRPr lang="sv-SE"/>
-          </a:p>
-        </p:txBody>
-      </p:sp>
-      <p:sp>
-        <p:nvSpPr>
-          <p:cNvPr id="69" name="Platshållare för text 68">
-            <a:extLst>
-              <a:ext uri="{FF2B5EF4-FFF2-40B4-BE49-F238E27FC236}">
-                <a16:creationId xmlns:a16="http://schemas.microsoft.com/office/drawing/2014/main" id="{BB711A32-EC33-40B5-9C82-5E6C1223DCD2}"/>
-              </a:ext>
-              <a:ext uri="{C183D7F6-B498-43B3-948B-1728B52AA6E4}">
-                <adec:decorative xmlns:adec="http://schemas.microsoft.com/office/drawing/2017/decorative" val="1"/>
-              </a:ext>
-            </a:extLst>
-          </p:cNvPr>
-          <p:cNvSpPr>
-            <a:spLocks noGrp="1"/>
-          </p:cNvSpPr>
-          <p:nvPr>
-            <p:ph type="body" sz="quarter" idx="19"/>
-          </p:nvPr>
-        </p:nvSpPr>
-        <p:spPr/>
-        <p:txBody>
-          <a:bodyPr rtlCol="0"/>
-          <a:lstStyle/>
-          <a:p>
-            <a:pPr rtl="0"/>
-            <a:endParaRPr lang="sv-SE"/>
+            <a:endParaRPr lang="sv-SE" noProof="0"/>
           </a:p>
         </p:txBody>
       </p:sp>
     </p:spTree>
     <p:extLst>
       <p:ext uri="{BB962C8B-B14F-4D97-AF65-F5344CB8AC3E}">
-        <p14:creationId xmlns:p14="http://schemas.microsoft.com/office/powerpoint/2010/main" val="63686572"/>
+        <p14:creationId xmlns:p14="http://schemas.microsoft.com/office/powerpoint/2010/main" val="1882903881"/>
       </p:ext>
     </p:extLst>
   </p:cSld>
@@ -18018,10 +18873,10 @@
       </p:grpSpPr>
       <p:sp>
         <p:nvSpPr>
-          <p:cNvPr id="9" name="Rubrik 8">
+          <p:cNvPr id="7" name="Rubrik 6">
             <a:extLst>
               <a:ext uri="{FF2B5EF4-FFF2-40B4-BE49-F238E27FC236}">
-                <a16:creationId xmlns:a16="http://schemas.microsoft.com/office/drawing/2014/main" id="{34CF6D46-0668-4D53-8C59-F859F6E2F309}"/>
+                <a16:creationId xmlns:a16="http://schemas.microsoft.com/office/drawing/2014/main" id="{BC31223B-F964-409B-BCFB-7D52E97E4054}"/>
               </a:ext>
             </a:extLst>
           </p:cNvPr>
@@ -18029,13 +18884,13 @@
             <a:spLocks noGrp="1"/>
           </p:cNvSpPr>
           <p:nvPr>
-            <p:ph type="ctrTitle"/>
+            <p:ph type="title"/>
           </p:nvPr>
         </p:nvSpPr>
         <p:spPr>
           <a:xfrm>
-            <a:off x="5430848" y="728905"/>
-            <a:ext cx="5922952" cy="3184274"/>
+            <a:off x="822352" y="566127"/>
+            <a:ext cx="10531448" cy="1490825"/>
           </a:xfrm>
         </p:spPr>
         <p:txBody>
@@ -18044,8 +18899,12 @@
           <a:p>
             <a:pPr rtl="0"/>
             <a:r>
+              <a:rPr lang="sv-SE" dirty="0"/>
+              <a:t>Implementation in </a:t>
+            </a:r>
+            <a:r>
               <a:rPr lang="sv-SE" dirty="0" err="1"/>
-              <a:t>Conclusion</a:t>
+              <a:t>Matlab</a:t>
             </a:r>
             <a:endParaRPr lang="sv-SE" dirty="0"/>
           </a:p>
@@ -18053,10 +18912,10 @@
       </p:sp>
       <p:sp>
         <p:nvSpPr>
-          <p:cNvPr id="14" name="Underrubrik 13">
+          <p:cNvPr id="8" name="Platshållare för text 7">
             <a:extLst>
               <a:ext uri="{FF2B5EF4-FFF2-40B4-BE49-F238E27FC236}">
-                <a16:creationId xmlns:a16="http://schemas.microsoft.com/office/drawing/2014/main" id="{6F5360D4-1E3B-45FC-B68E-C78D7F3797E1}"/>
+                <a16:creationId xmlns:a16="http://schemas.microsoft.com/office/drawing/2014/main" id="{F693D8AC-FF5F-4308-BD5D-F3629C785A2F}"/>
               </a:ext>
             </a:extLst>
           </p:cNvPr>
@@ -18064,13 +18923,61 @@
             <a:spLocks noGrp="1"/>
           </p:cNvSpPr>
           <p:nvPr>
-            <p:ph type="subTitle" idx="1"/>
+            <p:ph type="body" sz="quarter" idx="13"/>
           </p:nvPr>
         </p:nvSpPr>
         <p:spPr>
           <a:xfrm>
-            <a:off x="5397967" y="4072044"/>
-            <a:ext cx="5942079" cy="1495379"/>
+            <a:off x="1001991" y="2346854"/>
+            <a:ext cx="3698345" cy="552450"/>
+          </a:xfrm>
+        </p:spPr>
+        <p:txBody>
+          <a:bodyPr rtlCol="0">
+            <a:normAutofit/>
+          </a:bodyPr>
+          <a:lstStyle/>
+          <a:p>
+            <a:pPr rtl="0"/>
+            <a:r>
+              <a:rPr lang="sv-SE" dirty="0" err="1"/>
+              <a:t>Structure</a:t>
+            </a:r>
+            <a:r>
+              <a:rPr lang="sv-SE" dirty="0"/>
+              <a:t> </a:t>
+            </a:r>
+            <a:r>
+              <a:rPr lang="sv-SE" dirty="0" err="1"/>
+              <a:t>of</a:t>
+            </a:r>
+            <a:r>
+              <a:rPr lang="sv-SE" dirty="0"/>
+              <a:t> DQN and CNN</a:t>
+            </a:r>
+          </a:p>
+        </p:txBody>
+      </p:sp>
+      <p:sp>
+        <p:nvSpPr>
+          <p:cNvPr id="9" name="Platshållare för text 8">
+            <a:extLst>
+              <a:ext uri="{FF2B5EF4-FFF2-40B4-BE49-F238E27FC236}">
+                <a16:creationId xmlns:a16="http://schemas.microsoft.com/office/drawing/2014/main" id="{FCA99590-DAB9-4B30-8543-1BC95BF0E583}"/>
+              </a:ext>
+            </a:extLst>
+          </p:cNvPr>
+          <p:cNvSpPr>
+            <a:spLocks noGrp="1"/>
+          </p:cNvSpPr>
+          <p:nvPr>
+            <p:ph type="body" sz="quarter" idx="14"/>
+          </p:nvPr>
+        </p:nvSpPr>
+        <p:spPr>
+          <a:xfrm>
+            <a:off x="1001641" y="2899269"/>
+            <a:ext cx="3303659" cy="3215781"/>
           </a:xfrm>
         </p:spPr>
         <p:txBody>
@@ -18080,90 +18987,198 @@
             <a:pPr rtl="0"/>
             <a:r>
               <a:rPr lang="sv-SE" dirty="0"/>
-              <a:t>In </a:t>
+              <a:t>Lägg till text, bilder, grafik och videoklipp. </a:t>
+            </a:r>
+          </a:p>
+          <a:p>
+            <a:pPr rtl="0"/>
+            <a:r>
+              <a:rPr lang="sv-SE" dirty="0"/>
+              <a:t>Lägga till övergångar, animeringar och rörelser. </a:t>
+            </a:r>
+          </a:p>
+          <a:p>
+            <a:pPr rtl="0"/>
+            <a:r>
+              <a:rPr lang="sv-SE" dirty="0"/>
+              <a:t>Spara på </a:t>
             </a:r>
             <a:r>
               <a:rPr lang="sv-SE" dirty="0" err="1"/>
-              <a:t>hindsight</a:t>
-            </a:r>
-            <a:endParaRPr lang="sv-SE" dirty="0"/>
-          </a:p>
-          <a:p>
-            <a:pPr rtl="0"/>
-            <a:r>
-              <a:rPr lang="sv-SE" dirty="0" err="1"/>
-              <a:t>Improvements</a:t>
-            </a:r>
-            <a:endParaRPr lang="sv-SE" dirty="0"/>
-          </a:p>
-          <a:p>
-            <a:pPr rtl="0"/>
-            <a:endParaRPr lang="sv-SE" dirty="0"/>
+              <a:t>OneDrive</a:t>
+            </a:r>
+            <a:r>
+              <a:rPr lang="sv-SE" dirty="0"/>
+              <a:t> för att komma åt dina presentationer via din dator, surfplatta eller mobil. </a:t>
+            </a:r>
           </a:p>
         </p:txBody>
       </p:sp>
-      <p:pic>
-        <p:nvPicPr>
-          <p:cNvPr id="24" name="Platshållare för bild 23" descr="luffarschack">
+      <p:sp>
+        <p:nvSpPr>
+          <p:cNvPr id="10" name="Platshållare för text 9">
             <a:extLst>
               <a:ext uri="{FF2B5EF4-FFF2-40B4-BE49-F238E27FC236}">
-                <a16:creationId xmlns:a16="http://schemas.microsoft.com/office/drawing/2014/main" id="{AE28B949-DD41-4FAB-9BFD-9B1865AB8C09}"/>
+                <a16:creationId xmlns:a16="http://schemas.microsoft.com/office/drawing/2014/main" id="{C39B7D33-F20A-4BEC-8297-45B83F439C9C}"/>
               </a:ext>
             </a:extLst>
           </p:cNvPr>
-          <p:cNvPicPr>
-            <a:picLocks noGrp="1" noChangeAspect="1"/>
-          </p:cNvPicPr>
+          <p:cNvSpPr>
+            <a:spLocks noGrp="1"/>
+          </p:cNvSpPr>
           <p:nvPr>
-            <p:ph type="pic" sz="quarter" idx="13"/>
-          </p:nvPr>
-        </p:nvPicPr>
-        <p:blipFill rotWithShape="1">
-          <a:blip r:embed="rId3"/>
-          <a:srcRect t="6382" b="6382"/>
-          <a:stretch/>
-        </p:blipFill>
+            <p:ph type="body" sz="quarter" idx="15"/>
+          </p:nvPr>
+        </p:nvSpPr>
         <p:spPr>
           <a:xfrm>
-            <a:off x="679450" y="574675"/>
-            <a:ext cx="4311650" cy="2820988"/>
+            <a:off x="4700336" y="2346854"/>
+            <a:ext cx="3056887" cy="552450"/>
           </a:xfrm>
         </p:spPr>
-      </p:pic>
-      <p:pic>
-        <p:nvPicPr>
-          <p:cNvPr id="25" name="Platshållare för bild 24" descr="Två personer som pratar vid en anslagstavla">
+        <p:txBody>
+          <a:bodyPr rtlCol="0"/>
+          <a:lstStyle/>
+          <a:p>
+            <a:pPr rtl="0"/>
+            <a:r>
+              <a:rPr lang="sv-SE" dirty="0"/>
+              <a:t>Designer </a:t>
+            </a:r>
+            <a:r>
+              <a:rPr lang="sv-SE" dirty="0" err="1"/>
+              <a:t>Apps</a:t>
+            </a:r>
+            <a:endParaRPr lang="sv-SE" dirty="0"/>
+          </a:p>
+        </p:txBody>
+      </p:sp>
+      <p:sp>
+        <p:nvSpPr>
+          <p:cNvPr id="11" name="Platshållare för text 10">
             <a:extLst>
               <a:ext uri="{FF2B5EF4-FFF2-40B4-BE49-F238E27FC236}">
-                <a16:creationId xmlns:a16="http://schemas.microsoft.com/office/drawing/2014/main" id="{D9EE4828-B1AC-4232-BEC3-CBCA0DD3D25B}"/>
+                <a16:creationId xmlns:a16="http://schemas.microsoft.com/office/drawing/2014/main" id="{FD94F5F1-88A3-4B13-8EBA-47DAB2DF00C9}"/>
               </a:ext>
             </a:extLst>
           </p:cNvPr>
-          <p:cNvPicPr>
-            <a:picLocks noGrp="1" noChangeAspect="1"/>
-          </p:cNvPicPr>
+          <p:cNvSpPr>
+            <a:spLocks noGrp="1"/>
+          </p:cNvSpPr>
           <p:nvPr>
-            <p:ph type="pic" sz="quarter" idx="14"/>
-          </p:nvPr>
-        </p:nvPicPr>
-        <p:blipFill rotWithShape="1">
-          <a:blip r:embed="rId4"/>
-          <a:srcRect t="709" b="709"/>
-          <a:stretch/>
-        </p:blipFill>
+            <p:ph type="body" sz="quarter" idx="16"/>
+          </p:nvPr>
+        </p:nvSpPr>
         <p:spPr>
           <a:xfrm>
-            <a:off x="679450" y="3487738"/>
-            <a:ext cx="4311650" cy="2833687"/>
+            <a:off x="4453478" y="2899269"/>
+            <a:ext cx="3303659" cy="3215781"/>
           </a:xfrm>
         </p:spPr>
-      </p:pic>
+        <p:txBody>
+          <a:bodyPr rtlCol="0"/>
+          <a:lstStyle/>
+          <a:p>
+            <a:pPr rtl="0"/>
+            <a:r>
+              <a:rPr lang="sv-SE"/>
+              <a:t>Öppna fönstret för Designidéer när du vill ändra bilden direkt. </a:t>
+            </a:r>
+          </a:p>
+          <a:p>
+            <a:pPr rtl="0"/>
+            <a:r>
+              <a:rPr lang="sv-SE"/>
+              <a:t>När det finns designidéer kommer vi att visa dem där. </a:t>
+            </a:r>
+          </a:p>
+        </p:txBody>
+      </p:sp>
       <p:sp>
         <p:nvSpPr>
-          <p:cNvPr id="11" name="Platshållare för datum 10">
+          <p:cNvPr id="12" name="Platshållare för text 11">
             <a:extLst>
               <a:ext uri="{FF2B5EF4-FFF2-40B4-BE49-F238E27FC236}">
-                <a16:creationId xmlns:a16="http://schemas.microsoft.com/office/drawing/2014/main" id="{078A1077-0C8F-4D90-8616-EE28EC3EF632}"/>
+                <a16:creationId xmlns:a16="http://schemas.microsoft.com/office/drawing/2014/main" id="{A1A115CA-6CAF-4A96-ADFB-04588C1A796E}"/>
+              </a:ext>
+            </a:extLst>
+          </p:cNvPr>
+          <p:cNvSpPr>
+            <a:spLocks noGrp="1"/>
+          </p:cNvSpPr>
+          <p:nvPr>
+            <p:ph type="body" sz="quarter" idx="17"/>
+          </p:nvPr>
+        </p:nvSpPr>
+        <p:spPr>
+          <a:xfrm>
+            <a:off x="7906017" y="2333139"/>
+            <a:ext cx="3303394" cy="552450"/>
+          </a:xfrm>
+        </p:spPr>
+        <p:txBody>
+          <a:bodyPr rtlCol="0"/>
+          <a:lstStyle/>
+          <a:p>
+            <a:pPr rtl="0"/>
+            <a:r>
+              <a:rPr lang="sv-SE" dirty="0" err="1"/>
+              <a:t>Training</a:t>
+            </a:r>
+            <a:r>
+              <a:rPr lang="sv-SE" dirty="0"/>
+              <a:t> Process</a:t>
+            </a:r>
+          </a:p>
+        </p:txBody>
+      </p:sp>
+      <p:sp>
+        <p:nvSpPr>
+          <p:cNvPr id="13" name="Platshållare för text 12">
+            <a:extLst>
+              <a:ext uri="{FF2B5EF4-FFF2-40B4-BE49-F238E27FC236}">
+                <a16:creationId xmlns:a16="http://schemas.microsoft.com/office/drawing/2014/main" id="{47E9186B-E5E8-41FD-BFEE-0E574ABA486A}"/>
+              </a:ext>
+            </a:extLst>
+          </p:cNvPr>
+          <p:cNvSpPr>
+            <a:spLocks noGrp="1"/>
+          </p:cNvSpPr>
+          <p:nvPr>
+            <p:ph type="body" sz="quarter" idx="18"/>
+          </p:nvPr>
+        </p:nvSpPr>
+        <p:spPr>
+          <a:xfrm>
+            <a:off x="7905666" y="2885554"/>
+            <a:ext cx="3303659" cy="3215781"/>
+          </a:xfrm>
+        </p:spPr>
+        <p:txBody>
+          <a:bodyPr rtlCol="0"/>
+          <a:lstStyle/>
+          <a:p>
+            <a:pPr rtl="0"/>
+            <a:r>
+              <a:rPr lang="sv-SE"/>
+              <a:t>Det här PowerPoint-temat använder en egen uppsättning färger, teckensnitt och effekter för att skapa det övergripande utseendet på de här bilderna. </a:t>
+            </a:r>
+          </a:p>
+          <a:p>
+            <a:pPr rtl="0"/>
+            <a:r>
+              <a:rPr lang="sv-SE"/>
+              <a:t>PowerPoint innehåller massor av teman för att ge din presentation precis rätt personlighet. </a:t>
+            </a:r>
+          </a:p>
+        </p:txBody>
+      </p:sp>
+      <p:sp>
+        <p:nvSpPr>
+          <p:cNvPr id="14" name="Platshållare för datum 13">
+            <a:extLst>
+              <a:ext uri="{FF2B5EF4-FFF2-40B4-BE49-F238E27FC236}">
+                <a16:creationId xmlns:a16="http://schemas.microsoft.com/office/drawing/2014/main" id="{D858F0E8-5723-4917-B2F4-1959CDA57357}"/>
               </a:ext>
             </a:extLst>
           </p:cNvPr>
@@ -18174,7 +19189,12 @@
             <p:ph type="dt" sz="half" idx="10"/>
           </p:nvPr>
         </p:nvSpPr>
-        <p:spPr/>
+        <p:spPr>
+          <a:xfrm>
+            <a:off x="838200" y="6400800"/>
+            <a:ext cx="2743200" cy="365125"/>
+          </a:xfrm>
+        </p:spPr>
         <p:txBody>
           <a:bodyPr rtlCol="0"/>
           <a:lstStyle/>
@@ -18189,10 +19209,10 @@
       </p:sp>
       <p:sp>
         <p:nvSpPr>
-          <p:cNvPr id="12" name="Platshållare för sidfot 11">
+          <p:cNvPr id="15" name="Platshållare för sidfot 14">
             <a:extLst>
               <a:ext uri="{FF2B5EF4-FFF2-40B4-BE49-F238E27FC236}">
-                <a16:creationId xmlns:a16="http://schemas.microsoft.com/office/drawing/2014/main" id="{A90567F7-E12B-4F4E-B800-9D1435624D66}"/>
+                <a16:creationId xmlns:a16="http://schemas.microsoft.com/office/drawing/2014/main" id="{89CE2F29-4F13-4337-8A82-25313F29D150}"/>
               </a:ext>
             </a:extLst>
           </p:cNvPr>
@@ -18203,7 +19223,12 @@
             <p:ph type="ftr" sz="quarter" idx="11"/>
           </p:nvPr>
         </p:nvSpPr>
-        <p:spPr/>
+        <p:spPr>
+          <a:xfrm>
+            <a:off x="4038600" y="6400800"/>
+            <a:ext cx="4114800" cy="365125"/>
+          </a:xfrm>
+        </p:spPr>
         <p:txBody>
           <a:bodyPr rtlCol="0"/>
           <a:lstStyle/>
@@ -18218,10 +19243,10 @@
       </p:sp>
       <p:sp>
         <p:nvSpPr>
-          <p:cNvPr id="13" name="Platshållare för bildnummer 12">
+          <p:cNvPr id="16" name="Platshållare för bildnummer 15">
             <a:extLst>
               <a:ext uri="{FF2B5EF4-FFF2-40B4-BE49-F238E27FC236}">
-                <a16:creationId xmlns:a16="http://schemas.microsoft.com/office/drawing/2014/main" id="{B9994D78-37C2-41B7-B7DD-EF7ED34BD407}"/>
+                <a16:creationId xmlns:a16="http://schemas.microsoft.com/office/drawing/2014/main" id="{B2486DC8-B909-491B-95D1-B14F3DEC88E3}"/>
               </a:ext>
             </a:extLst>
           </p:cNvPr>
@@ -18232,7 +19257,12 @@
             <p:ph type="sldNum" sz="quarter" idx="12"/>
           </p:nvPr>
         </p:nvSpPr>
-        <p:spPr/>
+        <p:spPr>
+          <a:xfrm>
+            <a:off x="8610600" y="6400800"/>
+            <a:ext cx="2743200" cy="365125"/>
+          </a:xfrm>
+        </p:spPr>
         <p:txBody>
           <a:bodyPr rtlCol="0"/>
           <a:lstStyle/>
@@ -18250,7 +19280,7 @@
     </p:spTree>
     <p:extLst>
       <p:ext uri="{BB962C8B-B14F-4D97-AF65-F5344CB8AC3E}">
-        <p14:creationId xmlns:p14="http://schemas.microsoft.com/office/powerpoint/2010/main" val="1670641188"/>
+        <p14:creationId xmlns:p14="http://schemas.microsoft.com/office/powerpoint/2010/main" val="4062003319"/>
       </p:ext>
     </p:extLst>
   </p:cSld>
@@ -18279,10 +19309,10 @@
       </p:grpSpPr>
       <p:sp>
         <p:nvSpPr>
-          <p:cNvPr id="4" name="Rubrik 3">
+          <p:cNvPr id="15" name="Rubrik 14">
             <a:extLst>
               <a:ext uri="{FF2B5EF4-FFF2-40B4-BE49-F238E27FC236}">
-                <a16:creationId xmlns:a16="http://schemas.microsoft.com/office/drawing/2014/main" id="{6F67426A-9C36-4C9E-B549-AD3B8874F193}"/>
+                <a16:creationId xmlns:a16="http://schemas.microsoft.com/office/drawing/2014/main" id="{3DFFF8FE-0B1F-4A34-8AE0-3608529C4AF5}"/>
               </a:ext>
             </a:extLst>
           </p:cNvPr>
@@ -18290,59 +19320,13 @@
             <a:spLocks noGrp="1"/>
           </p:cNvSpPr>
           <p:nvPr>
-            <p:ph type="ctrTitle"/>
+            <p:ph type="title"/>
           </p:nvPr>
         </p:nvSpPr>
         <p:spPr>
           <a:xfrm>
-            <a:off x="485634" y="728905"/>
-            <a:ext cx="5893683" cy="3184274"/>
-          </a:xfrm>
-        </p:spPr>
-        <p:txBody>
-          <a:bodyPr rtlCol="0"/>
-          <a:lstStyle/>
-          <a:p>
-            <a:pPr rtl="0"/>
-            <a:r>
-              <a:rPr lang="sv-SE" dirty="0" err="1"/>
-              <a:t>Thanks</a:t>
-            </a:r>
-            <a:r>
-              <a:rPr lang="sv-SE" dirty="0"/>
-              <a:t> for </a:t>
-            </a:r>
-            <a:r>
-              <a:rPr lang="sv-SE" dirty="0" err="1"/>
-              <a:t>listening</a:t>
-            </a:r>
-            <a:r>
-              <a:rPr lang="sv-SE" dirty="0"/>
-              <a:t>!</a:t>
-            </a:r>
-          </a:p>
-        </p:txBody>
-      </p:sp>
-      <p:sp>
-        <p:nvSpPr>
-          <p:cNvPr id="6" name="Underrubrik 5">
-            <a:extLst>
-              <a:ext uri="{FF2B5EF4-FFF2-40B4-BE49-F238E27FC236}">
-                <a16:creationId xmlns:a16="http://schemas.microsoft.com/office/drawing/2014/main" id="{A9D6F00D-881F-4920-89F9-792BA92E543D}"/>
-              </a:ext>
-            </a:extLst>
-          </p:cNvPr>
-          <p:cNvSpPr>
-            <a:spLocks noGrp="1"/>
-          </p:cNvSpPr>
-          <p:nvPr>
-            <p:ph type="body" sz="quarter" idx="14"/>
-          </p:nvPr>
-        </p:nvSpPr>
-        <p:spPr>
-          <a:xfrm>
-            <a:off x="452754" y="4092681"/>
-            <a:ext cx="5926564" cy="2500206"/>
+            <a:off x="580403" y="4038599"/>
+            <a:ext cx="4715498" cy="2235494"/>
           </a:xfrm>
         </p:spPr>
         <p:txBody>
@@ -18353,32 +19337,148 @@
           <a:p>
             <a:pPr rtl="0"/>
             <a:r>
+              <a:rPr lang="sv-SE" sz="3200" dirty="0"/>
+              <a:t>Visual Representation</a:t>
+            </a:r>
+          </a:p>
+        </p:txBody>
+      </p:sp>
+      <p:pic>
+        <p:nvPicPr>
+          <p:cNvPr id="17" name="Platshållare för bild 16" descr="Närbild av ett schackbräde">
+            <a:extLst>
+              <a:ext uri="{FF2B5EF4-FFF2-40B4-BE49-F238E27FC236}">
+                <a16:creationId xmlns:a16="http://schemas.microsoft.com/office/drawing/2014/main" id="{ECCAD670-7062-4CD7-93ED-6AA7C8BBFF45}"/>
+              </a:ext>
+            </a:extLst>
+          </p:cNvPr>
+          <p:cNvPicPr>
+            <a:picLocks noGrp="1" noChangeAspect="1"/>
+          </p:cNvPicPr>
+          <p:nvPr>
+            <p:ph type="pic" sz="quarter" idx="14"/>
+          </p:nvPr>
+        </p:nvPicPr>
+        <p:blipFill rotWithShape="1">
+          <a:blip r:embed="rId3" cstate="screen">
+            <a:extLst>
+              <a:ext uri="{28A0092B-C50C-407E-A947-70E740481C1C}">
+                <a14:useLocalDpi xmlns:a14="http://schemas.microsoft.com/office/drawing/2010/main" val="0"/>
+              </a:ext>
+            </a:extLst>
+          </a:blip>
+          <a:srcRect/>
+          <a:stretch/>
+        </p:blipFill>
+        <p:spPr>
+          <a:xfrm>
+            <a:off x="581025" y="533400"/>
+            <a:ext cx="3628551" cy="3297238"/>
+          </a:xfrm>
+        </p:spPr>
+      </p:pic>
+      <p:pic>
+        <p:nvPicPr>
+          <p:cNvPr id="21" name="Platshållare för bild 20" descr="Närbild av ett schackbräde">
+            <a:extLst>
+              <a:ext uri="{FF2B5EF4-FFF2-40B4-BE49-F238E27FC236}">
+                <a16:creationId xmlns:a16="http://schemas.microsoft.com/office/drawing/2014/main" id="{2591A087-C8F7-43B5-8D57-C7D61C00B2E6}"/>
+              </a:ext>
+            </a:extLst>
+          </p:cNvPr>
+          <p:cNvPicPr>
+            <a:picLocks noGrp="1" noChangeAspect="1"/>
+          </p:cNvPicPr>
+          <p:nvPr>
+            <p:ph type="pic" sz="quarter" idx="15"/>
+          </p:nvPr>
+        </p:nvPicPr>
+        <p:blipFill rotWithShape="1">
+          <a:blip r:embed="rId4" cstate="screen">
+            <a:extLst>
+              <a:ext uri="{28A0092B-C50C-407E-A947-70E740481C1C}">
+                <a14:useLocalDpi xmlns:a14="http://schemas.microsoft.com/office/drawing/2010/main" val="0"/>
+              </a:ext>
+            </a:extLst>
+          </a:blip>
+          <a:srcRect/>
+          <a:stretch/>
+        </p:blipFill>
+        <p:spPr>
+          <a:xfrm>
+            <a:off x="4291941" y="533400"/>
+            <a:ext cx="3663496" cy="3297238"/>
+          </a:xfrm>
+        </p:spPr>
+      </p:pic>
+      <p:pic>
+        <p:nvPicPr>
+          <p:cNvPr id="26" name="Platshållare för bild 25" descr="En person som visar ritningar på pappersark med en penna">
+            <a:extLst>
+              <a:ext uri="{FF2B5EF4-FFF2-40B4-BE49-F238E27FC236}">
+                <a16:creationId xmlns:a16="http://schemas.microsoft.com/office/drawing/2014/main" id="{099D8543-3EEB-4227-9701-35025090F534}"/>
+              </a:ext>
+            </a:extLst>
+          </p:cNvPr>
+          <p:cNvPicPr>
+            <a:picLocks noGrp="1" noChangeAspect="1"/>
+          </p:cNvPicPr>
+          <p:nvPr>
+            <p:ph type="pic" sz="quarter" idx="16"/>
+          </p:nvPr>
+        </p:nvPicPr>
+        <p:blipFill rotWithShape="1">
+          <a:blip r:embed="rId5"/>
+          <a:srcRect l="13072" r="13072"/>
+          <a:stretch/>
+        </p:blipFill>
+        <p:spPr>
+          <a:xfrm>
+            <a:off x="8032564" y="533400"/>
+            <a:ext cx="3653023" cy="3297238"/>
+          </a:xfrm>
+        </p:spPr>
+      </p:pic>
+      <p:sp>
+        <p:nvSpPr>
+          <p:cNvPr id="16" name="Platshållare för text 15">
+            <a:extLst>
+              <a:ext uri="{FF2B5EF4-FFF2-40B4-BE49-F238E27FC236}">
+                <a16:creationId xmlns:a16="http://schemas.microsoft.com/office/drawing/2014/main" id="{79D3D0B4-CC43-4279-8230-0E15CA6CC587}"/>
+              </a:ext>
+            </a:extLst>
+          </p:cNvPr>
+          <p:cNvSpPr>
+            <a:spLocks noGrp="1"/>
+          </p:cNvSpPr>
+          <p:nvPr>
+            <p:ph type="body" sz="quarter" idx="13"/>
+          </p:nvPr>
+        </p:nvSpPr>
+        <p:spPr>
+          <a:xfrm>
+            <a:off x="5486400" y="4038600"/>
+            <a:ext cx="6199189" cy="2235200"/>
+          </a:xfrm>
+        </p:spPr>
+        <p:txBody>
+          <a:bodyPr rtlCol="0"/>
+          <a:lstStyle/>
+          <a:p>
+            <a:pPr rtl="0"/>
+            <a:r>
               <a:rPr lang="sv-SE"/>
-              <a:t>Namn på presentatör</a:t>
-            </a:r>
-          </a:p>
-          <a:p>
-            <a:pPr rtl="0"/>
-            <a:r>
-              <a:rPr lang="sv-SE"/>
-              <a:t>E-post</a:t>
-            </a:r>
-          </a:p>
-          <a:p>
-            <a:pPr rtl="0"/>
-            <a:r>
-              <a:rPr lang="sv-SE"/>
-              <a:t>Webbplats</a:t>
+              <a:t>Med PowerPoint kan du skapa presentationer och dela ditt arbete med andra, oavsett var de befinner sig. Skriv in den text du vill använda för att komma igång. Du kan också lägga till bilder, konst och videor i den här mallen. Spara till OneDrive och få åtkomst till dina presentationer från din dator, surfplatta eller mobil.</a:t>
             </a:r>
           </a:p>
         </p:txBody>
       </p:sp>
       <p:sp>
         <p:nvSpPr>
-          <p:cNvPr id="9" name="Platshållare för datum 8">
+          <p:cNvPr id="22" name="Platshållare för datum 21">
             <a:extLst>
               <a:ext uri="{FF2B5EF4-FFF2-40B4-BE49-F238E27FC236}">
-                <a16:creationId xmlns:a16="http://schemas.microsoft.com/office/drawing/2014/main" id="{3087E772-2F2C-4C47-BBBF-7E764029EAFA}"/>
+                <a16:creationId xmlns:a16="http://schemas.microsoft.com/office/drawing/2014/main" id="{24499858-7E09-42AB-A3F0-2C1068A4836A}"/>
               </a:ext>
             </a:extLst>
           </p:cNvPr>
@@ -18409,10 +19509,10 @@
       </p:sp>
       <p:sp>
         <p:nvSpPr>
-          <p:cNvPr id="10" name="Platshållare för sidfot 9">
+          <p:cNvPr id="23" name="Platshållare för sidfot 22">
             <a:extLst>
               <a:ext uri="{FF2B5EF4-FFF2-40B4-BE49-F238E27FC236}">
-                <a16:creationId xmlns:a16="http://schemas.microsoft.com/office/drawing/2014/main" id="{C43915F4-91EA-41AF-93B6-5D572A9EF60D}"/>
+                <a16:creationId xmlns:a16="http://schemas.microsoft.com/office/drawing/2014/main" id="{B3628A90-EE87-4FE9-AA39-875917A80C76}"/>
               </a:ext>
             </a:extLst>
           </p:cNvPr>
@@ -18425,8 +19525,8 @@
         </p:nvSpPr>
         <p:spPr>
           <a:xfrm>
-            <a:off x="3581400" y="6400800"/>
-            <a:ext cx="3657600" cy="365125"/>
+            <a:off x="4038600" y="6400800"/>
+            <a:ext cx="4114800" cy="365125"/>
           </a:xfrm>
         </p:spPr>
         <p:txBody>
@@ -18441,46 +19541,12 @@
           </a:p>
         </p:txBody>
       </p:sp>
-      <p:pic>
-        <p:nvPicPr>
-          <p:cNvPr id="18" name="Platshållare för bild 17" descr="Närbild av ett schackbräde">
+      <p:sp>
+        <p:nvSpPr>
+          <p:cNvPr id="24" name="Platshållare för bildnummer 23">
             <a:extLst>
               <a:ext uri="{FF2B5EF4-FFF2-40B4-BE49-F238E27FC236}">
-                <a16:creationId xmlns:a16="http://schemas.microsoft.com/office/drawing/2014/main" id="{5321AB55-5509-4588-ABEC-5DFF2EFF6B53}"/>
-              </a:ext>
-            </a:extLst>
-          </p:cNvPr>
-          <p:cNvPicPr>
-            <a:picLocks noGrp="1" noChangeAspect="1"/>
-          </p:cNvPicPr>
-          <p:nvPr>
-            <p:ph type="pic" sz="quarter" idx="13"/>
-          </p:nvPr>
-        </p:nvPicPr>
-        <p:blipFill rotWithShape="1">
-          <a:blip r:embed="rId3" cstate="screen">
-            <a:extLst>
-              <a:ext uri="{28A0092B-C50C-407E-A947-70E740481C1C}">
-                <a14:useLocalDpi xmlns:a14="http://schemas.microsoft.com/office/drawing/2010/main" val="0"/>
-              </a:ext>
-            </a:extLst>
-          </a:blip>
-          <a:srcRect/>
-          <a:stretch/>
-        </p:blipFill>
-        <p:spPr>
-          <a:xfrm>
-            <a:off x="7331075" y="0"/>
-            <a:ext cx="4860925" cy="6858000"/>
-          </a:xfrm>
-        </p:spPr>
-      </p:pic>
-      <p:sp>
-        <p:nvSpPr>
-          <p:cNvPr id="16" name="Platshållare för bildnummer 15">
-            <a:extLst>
-              <a:ext uri="{FF2B5EF4-FFF2-40B4-BE49-F238E27FC236}">
-                <a16:creationId xmlns:a16="http://schemas.microsoft.com/office/drawing/2014/main" id="{64D73EFD-BA26-43EF-A3B9-C2877D8A6F02}"/>
+                <a16:creationId xmlns:a16="http://schemas.microsoft.com/office/drawing/2014/main" id="{9481EC64-D6E1-4753-A68E-7C62AA16D214}"/>
               </a:ext>
             </a:extLst>
           </p:cNvPr>
@@ -18511,10 +19577,68 @@
           </a:p>
         </p:txBody>
       </p:sp>
+      <p:sp>
+        <p:nvSpPr>
+          <p:cNvPr id="68" name="Platshållare för text 67">
+            <a:extLst>
+              <a:ext uri="{FF2B5EF4-FFF2-40B4-BE49-F238E27FC236}">
+                <a16:creationId xmlns:a16="http://schemas.microsoft.com/office/drawing/2014/main" id="{A19C76D3-8EEC-4408-AEBF-59B910FB5DD9}"/>
+              </a:ext>
+              <a:ext uri="{C183D7F6-B498-43B3-948B-1728B52AA6E4}">
+                <adec:decorative xmlns:adec="http://schemas.microsoft.com/office/drawing/2017/decorative" val="1"/>
+              </a:ext>
+            </a:extLst>
+          </p:cNvPr>
+          <p:cNvSpPr>
+            <a:spLocks noGrp="1"/>
+          </p:cNvSpPr>
+          <p:nvPr>
+            <p:ph type="body" sz="quarter" idx="17"/>
+          </p:nvPr>
+        </p:nvSpPr>
+        <p:spPr/>
+        <p:txBody>
+          <a:bodyPr rtlCol="0"/>
+          <a:lstStyle/>
+          <a:p>
+            <a:pPr rtl="0"/>
+            <a:endParaRPr lang="sv-SE"/>
+          </a:p>
+        </p:txBody>
+      </p:sp>
+      <p:sp>
+        <p:nvSpPr>
+          <p:cNvPr id="69" name="Platshållare för text 68">
+            <a:extLst>
+              <a:ext uri="{FF2B5EF4-FFF2-40B4-BE49-F238E27FC236}">
+                <a16:creationId xmlns:a16="http://schemas.microsoft.com/office/drawing/2014/main" id="{BB711A32-EC33-40B5-9C82-5E6C1223DCD2}"/>
+              </a:ext>
+              <a:ext uri="{C183D7F6-B498-43B3-948B-1728B52AA6E4}">
+                <adec:decorative xmlns:adec="http://schemas.microsoft.com/office/drawing/2017/decorative" val="1"/>
+              </a:ext>
+            </a:extLst>
+          </p:cNvPr>
+          <p:cNvSpPr>
+            <a:spLocks noGrp="1"/>
+          </p:cNvSpPr>
+          <p:nvPr>
+            <p:ph type="body" sz="quarter" idx="19"/>
+          </p:nvPr>
+        </p:nvSpPr>
+        <p:spPr/>
+        <p:txBody>
+          <a:bodyPr rtlCol="0"/>
+          <a:lstStyle/>
+          <a:p>
+            <a:pPr rtl="0"/>
+            <a:endParaRPr lang="sv-SE" dirty="0"/>
+          </a:p>
+        </p:txBody>
+      </p:sp>
     </p:spTree>
     <p:extLst>
       <p:ext uri="{BB962C8B-B14F-4D97-AF65-F5344CB8AC3E}">
-        <p14:creationId xmlns:p14="http://schemas.microsoft.com/office/powerpoint/2010/main" val="279754773"/>
+        <p14:creationId xmlns:p14="http://schemas.microsoft.com/office/powerpoint/2010/main" val="63686572"/>
       </p:ext>
     </p:extLst>
   </p:cSld>

</xml_diff>